<commit_message>
Build: lymphedema/lipedema presentation site
Generated from src/content.json by src/build.py.
</commit_message>
<xml_diff>
--- a/Lymphedema_Lipedema_TBTW.pptx
+++ b/Lymphedema_Lipedema_TBTW.pptx
@@ -37,9 +37,11 @@
     <p:sldId id="285" r:id="rId31"/>
     <p:sldId id="286" r:id="rId32"/>
     <p:sldId id="287" r:id="rId33"/>
+    <p:sldId id="288" r:id="rId34"/>
+    <p:sldId id="289" r:id="rId35"/>
   </p:sldIdLst>
   <p:notesMasterIdLst>
-    <p:notesMasterId r:id="rId34"/>
+    <p:notesMasterId r:id="rId36"/>
   </p:notesMasterIdLst>
   <p:sldSz cx="12192000" cy="6858000"/>
   <p:notesSz cx="6858000" cy="12192000"/>
@@ -622,7 +624,17 @@
           <a:p>
             <a:r>
               <a:rPr lang="en-US" dirty="0"/>
-              <a:t>Severity by volume difference vs. the contralateral limb: minimal &lt;20%, moderate 20–40%, severe &gt;40%.</a:t>
+              <a:t>Severity by volume difference vs. the contralateral limb: minimal &lt;20%, moderate 20–40%, severe &gt;40%.
+SUGGESTED IMAGES FOR THIS SLIDE
+Save as: dx_stemmer_positive.png
+· Wikimedia — “Stemmer sign”
+  https://commons.wikimedia.org/w/index.php?search=Stemmer%20sign&amp;title=Special:MediaSearch&amp;type=image
+· Wikimedia — “pitting edema”
+  https://commons.wikimedia.org/w/index.php?search=pitting%20edema&amp;title=Special:MediaSearch&amp;type=image
+· Servier (CC BY) — “lymphoscintigraphy”
+  https://smart.servier.com/?s=lymphoscintigraphy
+· Wikimedia — “limb circumference measurement”
+  https://commons.wikimedia.org/w/index.php?search=limb%20circumference%20measurement&amp;title=Special:MediaSearch&amp;type=image</a:t>
             </a:r>
             <a:endParaRPr lang="en-US" dirty="0"/>
           </a:p>
@@ -711,7 +723,14 @@
             <a:r>
               <a:rPr lang="en-US" dirty="0"/>
               <a:t>[OPTIONAL — safe to cut]
-Malignant lymphedema and DVT are the two that must not be missed. Both are referrals, not treatment plans.</a:t>
+Malignant lymphedema and DVT are the two that must not be missed. Both are referrals, not treatment plans.
+SUGGESTED IMAGES FOR THIS SLIDE
+· Wikimedia — “deep vein thrombosis leg”
+  https://commons.wikimedia.org/w/index.php?search=deep%20vein%20thrombosis%20leg&amp;title=Special:MediaSearch&amp;type=image
+· Wikimedia — “chronic venous insufficiency”
+  https://commons.wikimedia.org/w/index.php?search=chronic%20venous%20insufficiency&amp;title=Special:MediaSearch&amp;type=image
+· Wikimedia — “cellulitis leg”
+  https://commons.wikimedia.org/w/index.php?search=cellulitis%20leg&amp;title=Special:MediaSearch&amp;type=image</a:t>
             </a:r>
             <a:endParaRPr lang="en-US" dirty="0"/>
           </a:p>
@@ -799,7 +818,13 @@
           <a:p>
             <a:r>
               <a:rPr lang="en-US" dirty="0"/>
-              <a:t>Staging describes tissue condition, not size. A small Stage III limb is still Stage III. Severity is graded separately by volume difference.</a:t>
+              <a:t>Staging describes tissue condition, not size. A small Stage III limb is still Stage III. Severity is graded separately by volume difference.
+SUGGESTED IMAGES FOR THIS SLIDE
+Save as: stage_clinical_leg.png
+· Wikimedia — “lymphedema stages”
+  https://commons.wikimedia.org/w/index.php?search=lymphedema%20stages&amp;title=Special:MediaSearch&amp;type=image
+· Servier (CC BY) — “lymphedema”
+  https://smart.servier.com/?s=lymphedema</a:t>
             </a:r>
             <a:endParaRPr lang="en-US" dirty="0"/>
           </a:p>
@@ -887,7 +912,12 @@
           <a:p>
             <a:r>
               <a:rPr lang="en-US" dirty="0"/>
-              <a:t>Photo slot: Stage 0 — no visible change; consider a limb-surveillance/measurement photo instead</a:t>
+              <a:t>Photo slot: Stage 0 — no visible change; consider a limb-surveillance/measurement photo instead
+SUGGESTED IMAGES FOR THIS SLIDE
+· Wikimedia — “bioimpedance lymphedema”
+  https://commons.wikimedia.org/w/index.php?search=bioimpedance%20lymphedema&amp;title=Special:MediaSearch&amp;type=image
+· Wikimedia — “limb measurement tape”
+  https://commons.wikimedia.org/w/index.php?search=limb%20measurement%20tape&amp;title=Special:MediaSearch&amp;type=image</a:t>
             </a:r>
             <a:endParaRPr lang="en-US" dirty="0"/>
           </a:p>
@@ -975,7 +1005,13 @@
           <a:p>
             <a:r>
               <a:rPr lang="en-US" dirty="0"/>
-              <a:t>Photo slot: Stage I — soft pitting edema, dorsum of foot or hand</a:t>
+              <a:t>Photo slot: Stage I — soft pitting edema, dorsum of foot or hand
+SUGGESTED IMAGES FOR THIS SLIDE
+Save as: stage1_photo.png
+· Wikimedia — “pitting edema foot”
+  https://commons.wikimedia.org/w/index.php?search=pitting%20edema%20foot&amp;title=Special:MediaSearch&amp;type=image
+· Wikimedia — “lymphedema early stage”
+  https://commons.wikimedia.org/w/index.php?search=lymphedema%20early%20stage&amp;title=Special:MediaSearch&amp;type=image</a:t>
             </a:r>
             <a:endParaRPr lang="en-US" dirty="0"/>
           </a:p>
@@ -1064,7 +1100,13 @@
             <a:r>
               <a:rPr lang="en-US" dirty="0"/>
               <a:t>The presence or absence of pitting is what separates early from late Stage II — not the size of the limb.
-Photo slot: Stage II — firm non-pitting swelling, positive Stemmer, early skin thickening</a:t>
+Photo slot: Stage II — firm non-pitting swelling, positive Stemmer, early skin thickening
+SUGGESTED IMAGES FOR THIS SLIDE
+Save as: stage2_photo.png
+· Wikimedia — “lymphedema fibrosis”
+  https://commons.wikimedia.org/w/index.php?search=lymphedema%20fibrosis&amp;title=Special:MediaSearch&amp;type=image
+· Wikimedia — “Stemmer sign positive”
+  https://commons.wikimedia.org/w/index.php?search=Stemmer%20sign%20positive&amp;title=Special:MediaSearch&amp;type=image</a:t>
             </a:r>
             <a:endParaRPr lang="en-US" dirty="0"/>
           </a:p>
@@ -1153,7 +1195,15 @@
             <a:r>
               <a:rPr lang="en-US" dirty="0"/>
               <a:t>Stage III is not a treatment failure to be managed passively. Significant reduction is well documented with sustained CDT.
-Photo slot: Stage III — elephantiasis, papillomas, deep skin folds</a:t>
+Photo slot: Stage III — elephantiasis, papillomas, deep skin folds
+SUGGESTED IMAGES FOR THIS SLIDE
+Save as: stage3_photo.png
+· Wikimedia — “elephantiasis leg”
+  https://commons.wikimedia.org/w/index.php?search=elephantiasis%20leg&amp;title=Special:MediaSearch&amp;type=image
+· Wikimedia — “lymphostatic elephantiasis”
+  https://commons.wikimedia.org/w/index.php?search=lymphostatic%20elephantiasis&amp;title=Special:MediaSearch&amp;type=image
+· Wikimedia — “papillomatosis skin”
+  https://commons.wikimedia.org/w/index.php?search=papillomatosis%20skin&amp;title=Special:MediaSearch&amp;type=image</a:t>
             </a:r>
             <a:endParaRPr lang="en-US" dirty="0"/>
           </a:p>
@@ -1241,7 +1291,13 @@
           <a:p>
             <a:r>
               <a:rPr lang="en-US" dirty="0"/>
-              <a:t>Phase II is where outcomes are actually won or lost. Adherence, not technique, is the usual determinant of long-term result.</a:t>
+              <a:t>Phase II is where outcomes are actually won or lost. Adherence, not technique, is the usual determinant of long-term result.
+SUGGESTED IMAGES FOR THIS SLIDE
+Save as: tx_before_after.png
+· Wikimedia — “complete decongestive therapy”
+  https://commons.wikimedia.org/w/index.php?search=complete%20decongestive%20therapy&amp;title=Special:MediaSearch&amp;type=image
+· Wikimedia — “lymphedema before after treatment”
+  https://commons.wikimedia.org/w/index.php?search=lymphedema%20before%20after%20treatment&amp;title=Special:MediaSearch&amp;type=image</a:t>
             </a:r>
             <a:endParaRPr lang="en-US" dirty="0"/>
           </a:p>
@@ -1417,7 +1473,13 @@
           <a:p>
             <a:r>
               <a:rPr lang="en-US" dirty="0"/>
-              <a:t/>
+              <a:t>SUGGESTED IMAGES FOR THIS SLIDE
+· Wikimedia — “emollient application skin”
+  https://commons.wikimedia.org/w/index.php?search=emollient%20application%20skin&amp;title=Special:MediaSearch&amp;type=image
+· Wikimedia — “tinea pedis”
+  https://commons.wikimedia.org/w/index.php?search=tinea%20pedis&amp;title=Special:MediaSearch&amp;type=image
+· Wikimedia — “cellulitis leg”
+  https://commons.wikimedia.org/w/index.php?search=cellulitis%20leg&amp;title=Special:MediaSearch&amp;type=image</a:t>
             </a:r>
             <a:endParaRPr lang="en-US" dirty="0"/>
           </a:p>
@@ -1593,7 +1655,15 @@
           <a:p>
             <a:r>
               <a:rPr lang="en-US" dirty="0"/>
-              <a:t>MLD alone produces modest results. Its value is greatest when combined with compression — the evidence supports CDT as a package, not MLD in isolation.</a:t>
+              <a:t>MLD alone produces modest results. Its value is greatest when combined with compression — the evidence supports CDT as a package, not MLD in isolation.
+SUGGESTED IMAGES FOR THIS SLIDE
+Save as: tx_mld_hands.png
+· Wikimedia — “manual lymphatic drainage”
+  https://commons.wikimedia.org/w/index.php?search=manual%20lymphatic%20drainage&amp;title=Special:MediaSearch&amp;type=image
+· Servier (CC BY) — “lymphatic drainage”
+  https://smart.servier.com/?s=lymphatic%20drainage
+· Wikimedia — “lymphatic watershed”
+  https://commons.wikimedia.org/w/index.php?search=lymphatic%20watershed&amp;title=Special:MediaSearch&amp;type=image</a:t>
             </a:r>
             <a:endParaRPr lang="en-US" dirty="0"/>
           </a:p>
@@ -1681,7 +1751,15 @@
           <a:p>
             <a:r>
               <a:rPr lang="en-US" dirty="0"/>
-              <a:t>MLD alone produces modest results. Its value is greatest when combined with compression — the evidence supports CDT as a package, not MLD in isolation.</a:t>
+              <a:t>MLD alone produces modest results. Its value is greatest when combined with compression — the evidence supports CDT as a package, not MLD in isolation.
+SUGGESTED IMAGES FOR THIS SLIDE
+Save as: tx_mld_hands.png
+· Wikimedia — “manual lymphatic drainage”
+  https://commons.wikimedia.org/w/index.php?search=manual%20lymphatic%20drainage&amp;title=Special:MediaSearch&amp;type=image
+· Servier (CC BY) — “lymphatic drainage”
+  https://smart.servier.com/?s=lymphatic%20drainage
+· Wikimedia — “lymphatic watershed”
+  https://commons.wikimedia.org/w/index.php?search=lymphatic%20watershed&amp;title=Special:MediaSearch&amp;type=image</a:t>
             </a:r>
             <a:endParaRPr lang="en-US" dirty="0"/>
           </a:p>
@@ -1769,7 +1847,15 @@
           <a:p>
             <a:r>
               <a:rPr lang="en-US" dirty="0"/>
-              <a:t>Intermittent pneumatic compression may be a useful adjunct but does not replace MLD or bandaging, and must not be used over an untreated proximal obstruction.</a:t>
+              <a:t>Intermittent pneumatic compression may be a useful adjunct but does not replace MLD or bandaging, and must not be used over an untreated proximal obstruction.
+SUGGESTED IMAGES FOR THIS SLIDE
+Save as: tx_bandaging.png, tx_garment_flatknit.png
+· Wikimedia — “compression bandage leg”
+  https://commons.wikimedia.org/w/index.php?search=compression%20bandage%20leg&amp;title=Special:MediaSearch&amp;type=image
+· Wikimedia — “compression stocking”
+  https://commons.wikimedia.org/w/index.php?search=compression%20stocking&amp;title=Special:MediaSearch&amp;type=image
+· Wikimedia — “short stretch bandage”
+  https://commons.wikimedia.org/w/index.php?search=short%20stretch%20bandage&amp;title=Special:MediaSearch&amp;type=image</a:t>
             </a:r>
             <a:endParaRPr lang="en-US" dirty="0"/>
           </a:p>
@@ -1857,7 +1943,14 @@
           <a:p>
             <a:r>
               <a:rPr lang="en-US" dirty="0"/>
-              <a:t>Aquatic exercise is particularly effective — hydrostatic pressure provides uniform external compression while the patient moves.</a:t>
+              <a:t>Aquatic exercise is particularly effective — hydrostatic pressure provides uniform external compression while the patient moves.
+SUGGESTED IMAGES FOR THIS SLIDE
+· Wikimedia — “aquatic therapy pool”
+  https://commons.wikimedia.org/w/index.php?search=aquatic%20therapy%20pool&amp;title=Special:MediaSearch&amp;type=image
+· Wikimedia — “resistance training rehabilitation”
+  https://commons.wikimedia.org/w/index.php?search=resistance%20training%20rehabilitation&amp;title=Special:MediaSearch&amp;type=image
+· Wikimedia — “diaphragmatic breathing”
+  https://commons.wikimedia.org/w/index.php?search=diaphragmatic%20breathing&amp;title=Special:MediaSearch&amp;type=image</a:t>
             </a:r>
             <a:endParaRPr lang="en-US" dirty="0"/>
           </a:p>
@@ -1945,7 +2038,15 @@
           <a:p>
             <a:r>
               <a:rPr lang="en-US" dirty="0"/>
-              <a:t>Sarah Bramblette and patient advocacy groups have driven recent recognition, but average time to diagnosis remains measured in years.</a:t>
+              <a:t>Sarah Bramblette and patient advocacy groups have driven recent recognition, but average time to diagnosis remains measured in years.
+SUGGESTED IMAGES FOR THIS SLIDE
+Save as: lip_clinical_legs.png
+· Wikimedia — “lipedema”
+  https://commons.wikimedia.org/w/index.php?search=lipedema&amp;title=Special:MediaSearch&amp;type=image
+· Wikimedia — “lipedema legs”
+  https://commons.wikimedia.org/w/index.php?search=lipedema%20legs&amp;title=Special:MediaSearch&amp;type=image
+· Servier (CC BY) — “adipose tissue”
+  https://smart.servier.com/?s=adipose%20tissue</a:t>
             </a:r>
             <a:endParaRPr lang="en-US" dirty="0"/>
           </a:p>
@@ -2033,7 +2134,15 @@
           <a:p>
             <a:r>
               <a:rPr lang="en-US" dirty="0"/>
-              <a:t>Sarah Bramblette and patient advocacy groups have driven recent recognition, but average time to diagnosis remains measured in years.</a:t>
+              <a:t>Sarah Bramblette and patient advocacy groups have driven recent recognition, but average time to diagnosis remains measured in years.
+SUGGESTED IMAGES FOR THIS SLIDE
+Save as: lip_clinical_legs.png
+· Wikimedia — “lipedema”
+  https://commons.wikimedia.org/w/index.php?search=lipedema&amp;title=Special:MediaSearch&amp;type=image
+· Wikimedia — “lipedema legs”
+  https://commons.wikimedia.org/w/index.php?search=lipedema%20legs&amp;title=Special:MediaSearch&amp;type=image
+· Servier (CC BY) — “adipose tissue”
+  https://smart.servier.com/?s=adipose%20tissue</a:t>
             </a:r>
             <a:endParaRPr lang="en-US" dirty="0"/>
           </a:p>
@@ -2297,7 +2406,12 @@
           <a:p>
             <a:r>
               <a:rPr lang="en-US" dirty="0"/>
-              <a:t>They co-exist. Lipedema does not itself cause lymphedema — but central obesity, which frequently accompanies it, substantially raises lymphedema risk. Treat what you find.</a:t>
+              <a:t>They co-exist. Lipedema does not itself cause lymphedema — but central obesity, which frequently accompanies it, substantially raises lymphedema risk. Treat what you find.
+SUGGESTED IMAGES FOR THIS SLIDE
+· Wikimedia — “lipedema lymphedema comparison”
+  https://commons.wikimedia.org/w/index.php?search=lipedema%20lymphedema%20comparison&amp;title=Special:MediaSearch&amp;type=image
+· Wikimedia — “Stemmer sign”
+  https://commons.wikimedia.org/w/index.php?search=Stemmer%20sign&amp;title=Special:MediaSearch&amp;type=image</a:t>
             </a:r>
             <a:endParaRPr lang="en-US" dirty="0"/>
           </a:p>
@@ -2386,7 +2500,12 @@
             <a:r>
               <a:rPr lang="en-US" dirty="0"/>
               <a:t>[OPTIONAL — safe to cut]
-The single most valuable thing you may do is tell the patient this is a recognized disease and not a personal failure of willpower.</a:t>
+The single most valuable thing you may do is tell the patient this is a recognized disease and not a personal failure of willpower.
+SUGGESTED IMAGES FOR THIS SLIDE
+· Wikimedia — “compression stocking leg”
+  https://commons.wikimedia.org/w/index.php?search=compression%20stocking%20leg&amp;title=Special:MediaSearch&amp;type=image
+· Wikimedia — “aquatic therapy”
+  https://commons.wikimedia.org/w/index.php?search=aquatic%20therapy&amp;title=Special:MediaSearch&amp;type=image</a:t>
             </a:r>
             <a:endParaRPr lang="en-US" dirty="0"/>
           </a:p>
@@ -2562,7 +2681,12 @@
           <a:p>
             <a:r>
               <a:rPr lang="en-US" dirty="0"/>
-              <a:t>MLD is contraindicated in acute infection, acute DVT, and decompensated heart failure. When in doubt, do not treat — refer.</a:t>
+              <a:t>MLD is contraindicated in acute infection, acute DVT, and decompensated heart failure. When in doubt, do not treat — refer.
+SUGGESTED IMAGES FOR THIS SLIDE
+· Wikimedia — “cellulitis leg”
+  https://commons.wikimedia.org/w/index.php?search=cellulitis%20leg&amp;title=Special:MediaSearch&amp;type=image
+· Wikimedia — “deep vein thrombosis”
+  https://commons.wikimedia.org/w/index.php?search=deep%20vein%20thrombosis&amp;title=Special:MediaSearch&amp;type=image</a:t>
             </a:r>
             <a:endParaRPr lang="en-US" dirty="0"/>
           </a:p>
@@ -2650,7 +2774,8 @@
           <a:p>
             <a:r>
               <a:rPr lang="en-US" dirty="0"/>
-              <a:t>Ten takeaways. If you are short on time, 3, 5 and 7 are the ones they must leave with.</a:t>
+              <a:t>Reviewing these is fine. Reusing their figures in a published deck is not — most contain third-party images the authors did not clear for redistribution. Use the per-slide image links instead; those are openly licensed. Structure, sequencing, and teaching approach are free to borrow from anyone.
+Links are clickable in slideshow mode.</a:t>
             </a:r>
             <a:endParaRPr lang="en-US" dirty="0"/>
           </a:p>
@@ -2738,7 +2863,8 @@
           <a:p>
             <a:r>
               <a:rPr lang="en-US" dirty="0"/>
-              <a:t>Close here. Remind them the QR opens the quiz.</a:t>
+              <a:t>Reviewing these is fine. Reusing their figures in a published deck is not — most contain third-party images the authors did not clear for redistribution. Use the per-slide image links instead; those are openly licensed. Structure, sequencing, and teaching approach are free to borrow from anyone.
+Links are clickable in slideshow mode.</a:t>
             </a:r>
             <a:endParaRPr lang="en-US" dirty="0"/>
           </a:p>
@@ -2762,6 +2888,182 @@
             <a:fld id="{F7021451-1387-4CA6-816F-3879F97B5CBC}" type="slidenum">
               <a:rPr lang="en-US"/>
               <a:t>32</a:t>
+            </a:fld>
+            <a:endParaRPr lang="en-US"/>
+          </a:p>
+        </p:txBody>
+      </p:sp>
+    </p:spTree>
+    <p:extLst>
+      <p:ext uri="{BB962C8B-B14F-4D97-AF65-F5344CB8AC3E}">
+        <p14:creationId xmlns:p14="http://schemas.microsoft.com/office/powerpoint/2010/main" val="1024086991"/>
+      </p:ext>
+    </p:extLst>
+  </p:cSld>
+  <p:clrMapOvr>
+    <a:masterClrMapping/>
+  </p:clrMapOvr>
+</p:notes>
+</file>
+
+<file path=ppt/notesSlides/notesSlide33.xml><?xml version="1.0" encoding="utf-8"?>
+<p:notes xmlns:a="http://schemas.openxmlformats.org/drawingml/2006/main" xmlns:r="http://schemas.openxmlformats.org/officeDocument/2006/relationships" xmlns:p="http://schemas.openxmlformats.org/presentationml/2006/main">
+  <p:cSld>
+    <p:spTree>
+      <p:nvGrpSpPr>
+        <p:cNvPr id="1" name=""/>
+        <p:cNvGrpSpPr/>
+        <p:nvPr/>
+      </p:nvGrpSpPr>
+      <p:grpSpPr>
+        <a:xfrm>
+          <a:off x="0" y="0"/>
+          <a:ext cx="0" cy="0"/>
+          <a:chOff x="0" y="0"/>
+          <a:chExt cx="0" cy="0"/>
+        </a:xfrm>
+      </p:grpSpPr>
+      <p:sp>
+        <p:nvSpPr>
+          <p:cNvPr id="2" name="Slide Image Placeholder 1"/>
+          <p:cNvSpPr>
+            <a:spLocks noGrp="1" noRot="1" noChangeAspect="1"/>
+          </p:cNvSpPr>
+          <p:nvPr>
+            <p:ph type="sldImg"/>
+          </p:nvPr>
+        </p:nvSpPr>
+        <p:spPr/>
+      </p:sp>
+      <p:sp>
+        <p:nvSpPr>
+          <p:cNvPr id="3" name="Notes Placeholder 2"/>
+          <p:cNvSpPr>
+            <a:spLocks noGrp="1"/>
+          </p:cNvSpPr>
+          <p:nvPr>
+            <p:ph type="body" idx="1"/>
+          </p:nvPr>
+        </p:nvSpPr>
+        <p:spPr/>
+        <p:txBody>
+          <a:bodyPr/>
+          <a:lstStyle/>
+          <a:p>
+            <a:r>
+              <a:rPr lang="en-US" dirty="0"/>
+              <a:t>Ten takeaways. If you are short on time, 3, 5 and 7 are the ones they must leave with.</a:t>
+            </a:r>
+            <a:endParaRPr lang="en-US" dirty="0"/>
+          </a:p>
+        </p:txBody>
+      </p:sp>
+      <p:sp>
+        <p:nvSpPr>
+          <p:cNvPr id="4" name="Slide Number Placeholder 3"/>
+          <p:cNvSpPr>
+            <a:spLocks noGrp="1"/>
+          </p:cNvSpPr>
+          <p:nvPr>
+            <p:ph type="sldNum" sz="quarter" idx="10"/>
+          </p:nvPr>
+        </p:nvSpPr>
+        <p:spPr/>
+        <p:txBody>
+          <a:bodyPr/>
+          <a:lstStyle/>
+          <a:p>
+            <a:fld id="{F7021451-1387-4CA6-816F-3879F97B5CBC}" type="slidenum">
+              <a:rPr lang="en-US"/>
+              <a:t>33</a:t>
+            </a:fld>
+            <a:endParaRPr lang="en-US"/>
+          </a:p>
+        </p:txBody>
+      </p:sp>
+    </p:spTree>
+    <p:extLst>
+      <p:ext uri="{BB962C8B-B14F-4D97-AF65-F5344CB8AC3E}">
+        <p14:creationId xmlns:p14="http://schemas.microsoft.com/office/powerpoint/2010/main" val="1024086991"/>
+      </p:ext>
+    </p:extLst>
+  </p:cSld>
+  <p:clrMapOvr>
+    <a:masterClrMapping/>
+  </p:clrMapOvr>
+</p:notes>
+</file>
+
+<file path=ppt/notesSlides/notesSlide34.xml><?xml version="1.0" encoding="utf-8"?>
+<p:notes xmlns:a="http://schemas.openxmlformats.org/drawingml/2006/main" xmlns:r="http://schemas.openxmlformats.org/officeDocument/2006/relationships" xmlns:p="http://schemas.openxmlformats.org/presentationml/2006/main">
+  <p:cSld>
+    <p:spTree>
+      <p:nvGrpSpPr>
+        <p:cNvPr id="1" name=""/>
+        <p:cNvGrpSpPr/>
+        <p:nvPr/>
+      </p:nvGrpSpPr>
+      <p:grpSpPr>
+        <a:xfrm>
+          <a:off x="0" y="0"/>
+          <a:ext cx="0" cy="0"/>
+          <a:chOff x="0" y="0"/>
+          <a:chExt cx="0" cy="0"/>
+        </a:xfrm>
+      </p:grpSpPr>
+      <p:sp>
+        <p:nvSpPr>
+          <p:cNvPr id="2" name="Slide Image Placeholder 1"/>
+          <p:cNvSpPr>
+            <a:spLocks noGrp="1" noRot="1" noChangeAspect="1"/>
+          </p:cNvSpPr>
+          <p:nvPr>
+            <p:ph type="sldImg"/>
+          </p:nvPr>
+        </p:nvSpPr>
+        <p:spPr/>
+      </p:sp>
+      <p:sp>
+        <p:nvSpPr>
+          <p:cNvPr id="3" name="Notes Placeholder 2"/>
+          <p:cNvSpPr>
+            <a:spLocks noGrp="1"/>
+          </p:cNvSpPr>
+          <p:nvPr>
+            <p:ph type="body" idx="1"/>
+          </p:nvPr>
+        </p:nvSpPr>
+        <p:spPr/>
+        <p:txBody>
+          <a:bodyPr/>
+          <a:lstStyle/>
+          <a:p>
+            <a:r>
+              <a:rPr lang="en-US" dirty="0"/>
+              <a:t>Close here. Remind them the QR opens the quiz.</a:t>
+            </a:r>
+            <a:endParaRPr lang="en-US" dirty="0"/>
+          </a:p>
+        </p:txBody>
+      </p:sp>
+      <p:sp>
+        <p:nvSpPr>
+          <p:cNvPr id="4" name="Slide Number Placeholder 3"/>
+          <p:cNvSpPr>
+            <a:spLocks noGrp="1"/>
+          </p:cNvSpPr>
+          <p:nvPr>
+            <p:ph type="sldNum" sz="quarter" idx="10"/>
+          </p:nvPr>
+        </p:nvSpPr>
+        <p:spPr/>
+        <p:txBody>
+          <a:bodyPr/>
+          <a:lstStyle/>
+          <a:p>
+            <a:fld id="{F7021451-1387-4CA6-816F-3879F97B5CBC}" type="slidenum">
+              <a:rPr lang="en-US"/>
+              <a:t>34</a:t>
             </a:fld>
             <a:endParaRPr lang="en-US"/>
           </a:p>
@@ -2826,7 +3128,17 @@
           <a:p>
             <a:r>
               <a:rPr lang="en-US" dirty="0"/>
-              <a:t>Lymphangion contraction is the primary pump. It is stimulated by stretch, muscle contraction, arterial pulsation, and breathing — which is exactly why exercise and diaphragmatic breathing are treatment, not just adjuncts.</a:t>
+              <a:t>Lymphangion contraction is the primary pump. It is stimulated by stretch, muscle contraction, arterial pulsation, and breathing — which is exactly why exercise and diaphragmatic breathing are treatment, not just adjuncts.
+SUGGESTED IMAGES FOR THIS SLIDE
+Save as: anat_lymphatic_system.png, anat_openstax_system.png, anat_grays_thoracic_duct.png
+· Servier (CC BY) — “lymphatic system”
+  https://smart.servier.com/?s=lymphatic%20system
+· OpenStax Ch.21 (CC BY)
+  https://openstax.org/books/anatomy-and-physiology-2e/pages/21-1-anatomy-of-the-lymphatic-and-immune-systems
+· Wikimedia — “lymphatic system diagram”
+  https://commons.wikimedia.org/w/index.php?search=lymphatic%20system%20diagram&amp;title=Special:MediaSearch&amp;type=image
+· NCI (public domain) — “lymphatic system”
+  https://visualsonline.cancer.gov/search.cfm?criteria=lymphatic%20system</a:t>
             </a:r>
             <a:endParaRPr lang="en-US" dirty="0"/>
           </a:p>
@@ -2914,7 +3226,17 @@
           <a:p>
             <a:r>
               <a:rPr lang="en-US" dirty="0"/>
-              <a:t>Lymphangion contraction is the primary pump. It is stimulated by stretch, muscle contraction, arterial pulsation, and breathing — which is exactly why exercise and diaphragmatic breathing are treatment, not just adjuncts.</a:t>
+              <a:t>Lymphangion contraction is the primary pump. It is stimulated by stretch, muscle contraction, arterial pulsation, and breathing — which is exactly why exercise and diaphragmatic breathing are treatment, not just adjuncts.
+SUGGESTED IMAGES FOR THIS SLIDE
+Save as: anat_lymphatic_system.png, anat_openstax_system.png, anat_grays_thoracic_duct.png
+· Servier (CC BY) — “lymphatic system”
+  https://smart.servier.com/?s=lymphatic%20system
+· OpenStax Ch.21 (CC BY)
+  https://openstax.org/books/anatomy-and-physiology-2e/pages/21-1-anatomy-of-the-lymphatic-and-immune-systems
+· Wikimedia — “lymphatic system diagram”
+  https://commons.wikimedia.org/w/index.php?search=lymphatic%20system%20diagram&amp;title=Special:MediaSearch&amp;type=image
+· NCI (public domain) — “lymphatic system”
+  https://visualsonline.cancer.gov/search.cfm?criteria=lymphatic%20system</a:t>
             </a:r>
             <a:endParaRPr lang="en-US" dirty="0"/>
           </a:p>
@@ -3003,7 +3325,15 @@
             <a:r>
               <a:rPr lang="en-US" dirty="0"/>
               <a:t>[OPTIONAL — safe to cut]
-Combined insufficiency — high load AND damaged system — is common in the patients you will actually see.</a:t>
+Combined insufficiency — high load AND damaged system — is common in the patients you will actually see.
+SUGGESTED IMAGES FOR THIS SLIDE
+Save as: anat_lymph_capillary.png
+· Servier (CC BY) — “lymphatic capillary”
+  https://smart.servier.com/?s=lymphatic%20capillary
+· Wikimedia — “lymph capillary interstitial fluid”
+  https://commons.wikimedia.org/w/index.php?search=lymph%20capillary%20interstitial%20fluid&amp;title=Special:MediaSearch&amp;type=image
+· OpenStax Ch.21 (CC BY)
+  https://openstax.org/books/anatomy-and-physiology-2e/pages/21-1-anatomy-of-the-lymphatic-and-immune-systems</a:t>
             </a:r>
             <a:endParaRPr lang="en-US" dirty="0"/>
           </a:p>
@@ -3091,7 +3421,15 @@
           <a:p>
             <a:r>
               <a:rPr lang="en-US" dirty="0"/>
-              <a:t>Risk multipliers after cancer treatment: extent of node dissection, regional radiation, elevated BMI, post-op infection, wound complications, and taxane-based chemotherapy.</a:t>
+              <a:t>Risk multipliers after cancer treatment: extent of node dissection, regional radiation, elevated BMI, post-op infection, wound complications, and taxane-based chemotherapy.
+SUGGESTED IMAGES FOR THIS SLIDE
+Save as: anat_axillary_nodes.png, anat_node_regions.png
+· NCI (public domain) — “axillary lymph node”
+  https://visualsonline.cancer.gov/search.cfm?criteria=axillary%20lymph%20node
+· Servier (CC BY) — “lymph node”
+  https://smart.servier.com/?s=lymph%20node
+· Wikimedia — “lymph node dissection”
+  https://commons.wikimedia.org/w/index.php?search=lymph%20node%20dissection&amp;title=Special:MediaSearch&amp;type=image</a:t>
             </a:r>
             <a:endParaRPr lang="en-US" dirty="0"/>
           </a:p>
@@ -3179,7 +3517,15 @@
           <a:p>
             <a:r>
               <a:rPr lang="en-US" dirty="0"/>
-              <a:t>Lymphedema is typically painless early. New or significant pain suggests infection, DVT, malignancy — or lipedema, which is painful by definition.</a:t>
+              <a:t>Lymphedema is typically painless early. New or significant pain suggests infection, DVT, malignancy — or lipedema, which is painful by definition.
+SUGGESTED IMAGES FOR THIS SLIDE
+Save as: stage_clinical_leg.png
+· Wikimedia — “lymphedema arm”
+  https://commons.wikimedia.org/w/index.php?search=lymphedema%20arm&amp;title=Special:MediaSearch&amp;type=image
+· Wikimedia — “lymphedema leg”
+  https://commons.wikimedia.org/w/index.php?search=lymphedema%20leg&amp;title=Special:MediaSearch&amp;type=image
+· Servier (CC BY) — “edema”
+  https://smart.servier.com/?s=edema</a:t>
             </a:r>
             <a:endParaRPr lang="en-US" dirty="0"/>
           </a:p>
@@ -3267,7 +3613,17 @@
           <a:p>
             <a:r>
               <a:rPr lang="en-US" dirty="0"/>
-              <a:t>Severity by volume difference vs. the contralateral limb: minimal &lt;20%, moderate 20–40%, severe &gt;40%.</a:t>
+              <a:t>Severity by volume difference vs. the contralateral limb: minimal &lt;20%, moderate 20–40%, severe &gt;40%.
+SUGGESTED IMAGES FOR THIS SLIDE
+Save as: dx_stemmer_positive.png
+· Wikimedia — “Stemmer sign”
+  https://commons.wikimedia.org/w/index.php?search=Stemmer%20sign&amp;title=Special:MediaSearch&amp;type=image
+· Wikimedia — “pitting edema”
+  https://commons.wikimedia.org/w/index.php?search=pitting%20edema&amp;title=Special:MediaSearch&amp;type=image
+· Servier (CC BY) — “lymphoscintigraphy”
+  https://smart.servier.com/?s=lymphoscintigraphy
+· Wikimedia — “limb circumference measurement”
+  https://commons.wikimedia.org/w/index.php?search=limb%20circumference%20measurement&amp;title=Special:MediaSearch&amp;type=image</a:t>
             </a:r>
             <a:endParaRPr lang="en-US" dirty="0"/>
           </a:p>
@@ -4179,11 +4535,11 @@
         <p:spPr>
           <a:xfrm>
             <a:off x="566928" y="1572768"/>
-            <a:ext cx="5428336" cy="2504313"/>
+            <a:ext cx="5428336" cy="4718304"/>
           </a:xfrm>
           <a:prstGeom prst="roundRect">
             <a:avLst>
-              <a:gd name="adj" fmla="val 3286"/>
+              <a:gd name="adj" fmla="val 1744"/>
             </a:avLst>
           </a:prstGeom>
           <a:solidFill>
@@ -4245,7 +4601,7 @@
         <p:spPr>
           <a:xfrm>
             <a:off x="786384" y="2066544"/>
-            <a:ext cx="4989424" cy="1845945"/>
+            <a:ext cx="4989424" cy="4059936"/>
           </a:xfrm>
           <a:prstGeom prst="rect">
             <a:avLst/>
@@ -4419,11 +4775,11 @@
         <p:spPr>
           <a:xfrm>
             <a:off x="6196432" y="1572768"/>
-            <a:ext cx="5428336" cy="2044827"/>
+            <a:ext cx="5428336" cy="4718304"/>
           </a:xfrm>
           <a:prstGeom prst="roundRect">
             <a:avLst>
-              <a:gd name="adj" fmla="val 4025"/>
+              <a:gd name="adj" fmla="val 1744"/>
             </a:avLst>
           </a:prstGeom>
           <a:solidFill>
@@ -4485,7 +4841,7 @@
         <p:spPr>
           <a:xfrm>
             <a:off x="6415888" y="2066544"/>
-            <a:ext cx="4989424" cy="1386459"/>
+            <a:ext cx="4989424" cy="4059936"/>
           </a:xfrm>
           <a:prstGeom prst="rect">
             <a:avLst/>
@@ -6623,11 +6979,11 @@
         <p:spPr>
           <a:xfrm>
             <a:off x="566928" y="1572768"/>
-            <a:ext cx="5414620" cy="2057146"/>
+            <a:ext cx="5414620" cy="4718304"/>
           </a:xfrm>
           <a:prstGeom prst="roundRect">
             <a:avLst>
-              <a:gd name="adj" fmla="val 4000"/>
+              <a:gd name="adj" fmla="val 1744"/>
             </a:avLst>
           </a:prstGeom>
           <a:solidFill>
@@ -6689,7 +7045,7 @@
         <p:spPr>
           <a:xfrm>
             <a:off x="804672" y="2103120"/>
-            <a:ext cx="4939132" cy="1362202"/>
+            <a:ext cx="4939132" cy="4023360"/>
           </a:xfrm>
           <a:prstGeom prst="rect">
             <a:avLst/>
@@ -6816,11 +7172,11 @@
         <p:spPr>
           <a:xfrm>
             <a:off x="6210148" y="1572768"/>
-            <a:ext cx="5414620" cy="1781048"/>
+            <a:ext cx="5414620" cy="4718304"/>
           </a:xfrm>
           <a:prstGeom prst="roundRect">
             <a:avLst>
-              <a:gd name="adj" fmla="val 4621"/>
+              <a:gd name="adj" fmla="val 1744"/>
             </a:avLst>
           </a:prstGeom>
           <a:solidFill>
@@ -6882,7 +7238,7 @@
         <p:spPr>
           <a:xfrm>
             <a:off x="6447892" y="2103120"/>
-            <a:ext cx="4939132" cy="1086104"/>
+            <a:ext cx="4939132" cy="4023360"/>
           </a:xfrm>
           <a:prstGeom prst="rect">
             <a:avLst/>
@@ -7203,11 +7559,11 @@
         <p:spPr>
           <a:xfrm>
             <a:off x="566928" y="1572768"/>
-            <a:ext cx="5414620" cy="2057146"/>
+            <a:ext cx="5414620" cy="4718304"/>
           </a:xfrm>
           <a:prstGeom prst="roundRect">
             <a:avLst>
-              <a:gd name="adj" fmla="val 4000"/>
+              <a:gd name="adj" fmla="val 1744"/>
             </a:avLst>
           </a:prstGeom>
           <a:solidFill>
@@ -7269,7 +7625,7 @@
         <p:spPr>
           <a:xfrm>
             <a:off x="804672" y="2103120"/>
-            <a:ext cx="4939132" cy="1362202"/>
+            <a:ext cx="4939132" cy="4023360"/>
           </a:xfrm>
           <a:prstGeom prst="rect">
             <a:avLst/>
@@ -7413,11 +7769,11 @@
         <p:spPr>
           <a:xfrm>
             <a:off x="6210148" y="1572768"/>
-            <a:ext cx="5414620" cy="1781048"/>
+            <a:ext cx="5414620" cy="4718304"/>
           </a:xfrm>
           <a:prstGeom prst="roundRect">
             <a:avLst>
-              <a:gd name="adj" fmla="val 4621"/>
+              <a:gd name="adj" fmla="val 1744"/>
             </a:avLst>
           </a:prstGeom>
           <a:solidFill>
@@ -7479,7 +7835,7 @@
         <p:spPr>
           <a:xfrm>
             <a:off x="6447892" y="2103120"/>
-            <a:ext cx="4939132" cy="1086104"/>
+            <a:ext cx="4939132" cy="4023360"/>
           </a:xfrm>
           <a:prstGeom prst="rect">
             <a:avLst/>
@@ -7800,11 +8156,11 @@
         <p:spPr>
           <a:xfrm>
             <a:off x="566928" y="1572768"/>
-            <a:ext cx="5414620" cy="2333244"/>
+            <a:ext cx="5414620" cy="4151376"/>
           </a:xfrm>
           <a:prstGeom prst="roundRect">
             <a:avLst>
-              <a:gd name="adj" fmla="val 3527"/>
+              <a:gd name="adj" fmla="val 1982"/>
             </a:avLst>
           </a:prstGeom>
           <a:solidFill>
@@ -7866,7 +8222,7 @@
         <p:spPr>
           <a:xfrm>
             <a:off x="804672" y="2103120"/>
-            <a:ext cx="4939132" cy="1638300"/>
+            <a:ext cx="4939132" cy="3456432"/>
           </a:xfrm>
           <a:prstGeom prst="rect">
             <a:avLst/>
@@ -8048,11 +8404,11 @@
         <p:spPr>
           <a:xfrm>
             <a:off x="6210148" y="1572768"/>
-            <a:ext cx="5414620" cy="1781048"/>
+            <a:ext cx="5414620" cy="4151376"/>
           </a:xfrm>
           <a:prstGeom prst="roundRect">
             <a:avLst>
-              <a:gd name="adj" fmla="val 4621"/>
+              <a:gd name="adj" fmla="val 1982"/>
             </a:avLst>
           </a:prstGeom>
           <a:solidFill>
@@ -8114,7 +8470,7 @@
         <p:spPr>
           <a:xfrm>
             <a:off x="6447892" y="2103120"/>
-            <a:ext cx="4939132" cy="1086104"/>
+            <a:ext cx="4939132" cy="3456432"/>
           </a:xfrm>
           <a:prstGeom prst="rect">
             <a:avLst/>
@@ -8474,11 +8830,11 @@
         <p:spPr>
           <a:xfrm>
             <a:off x="566928" y="1572768"/>
-            <a:ext cx="5414620" cy="2885440"/>
+            <a:ext cx="5414620" cy="4151376"/>
           </a:xfrm>
           <a:prstGeom prst="roundRect">
             <a:avLst>
-              <a:gd name="adj" fmla="val 2852"/>
+              <a:gd name="adj" fmla="val 1982"/>
             </a:avLst>
           </a:prstGeom>
           <a:solidFill>
@@ -8540,7 +8896,7 @@
         <p:spPr>
           <a:xfrm>
             <a:off x="804672" y="2103120"/>
-            <a:ext cx="4939132" cy="2190496"/>
+            <a:ext cx="4939132" cy="3456432"/>
           </a:xfrm>
           <a:prstGeom prst="rect">
             <a:avLst/>
@@ -8770,11 +9126,11 @@
         <p:spPr>
           <a:xfrm>
             <a:off x="6210148" y="1572768"/>
-            <a:ext cx="5414620" cy="2223516"/>
+            <a:ext cx="5414620" cy="4151376"/>
           </a:xfrm>
           <a:prstGeom prst="roundRect">
             <a:avLst>
-              <a:gd name="adj" fmla="val 3701"/>
+              <a:gd name="adj" fmla="val 1982"/>
             </a:avLst>
           </a:prstGeom>
           <a:solidFill>
@@ -8836,7 +9192,7 @@
         <p:spPr>
           <a:xfrm>
             <a:off x="6447892" y="2103120"/>
-            <a:ext cx="4939132" cy="1528572"/>
+            <a:ext cx="4939132" cy="3456432"/>
           </a:xfrm>
           <a:prstGeom prst="rect">
             <a:avLst/>
@@ -9972,11 +10328,11 @@
         <p:spPr>
           <a:xfrm>
             <a:off x="566928" y="2231136"/>
-            <a:ext cx="3551834" cy="2734056"/>
+            <a:ext cx="3551834" cy="4059936"/>
           </a:xfrm>
           <a:prstGeom prst="roundRect">
             <a:avLst>
-              <a:gd name="adj" fmla="val 3010"/>
+              <a:gd name="adj" fmla="val 2317"/>
             </a:avLst>
           </a:prstGeom>
           <a:solidFill>
@@ -10038,7 +10394,7 @@
         <p:spPr>
           <a:xfrm>
             <a:off x="786384" y="2724912"/>
-            <a:ext cx="3112922" cy="2075688"/>
+            <a:ext cx="3112922" cy="3401568"/>
           </a:xfrm>
           <a:prstGeom prst="rect">
             <a:avLst/>
@@ -10144,11 +10500,11 @@
         <p:spPr>
           <a:xfrm>
             <a:off x="4319930" y="2231136"/>
-            <a:ext cx="3551834" cy="3248406"/>
+            <a:ext cx="3551834" cy="4059936"/>
           </a:xfrm>
           <a:prstGeom prst="roundRect">
             <a:avLst>
-              <a:gd name="adj" fmla="val 2533"/>
+              <a:gd name="adj" fmla="val 2317"/>
             </a:avLst>
           </a:prstGeom>
           <a:solidFill>
@@ -10210,7 +10566,7 @@
         <p:spPr>
           <a:xfrm>
             <a:off x="4539386" y="2724912"/>
-            <a:ext cx="3112922" cy="2590038"/>
+            <a:ext cx="3112922" cy="3401568"/>
           </a:xfrm>
           <a:prstGeom prst="rect">
             <a:avLst/>
@@ -10337,11 +10693,11 @@
         <p:spPr>
           <a:xfrm>
             <a:off x="8072933" y="2231136"/>
-            <a:ext cx="3551834" cy="2504313"/>
+            <a:ext cx="3551834" cy="4059936"/>
           </a:xfrm>
           <a:prstGeom prst="roundRect">
             <a:avLst>
-              <a:gd name="adj" fmla="val 3286"/>
+              <a:gd name="adj" fmla="val 2317"/>
             </a:avLst>
           </a:prstGeom>
           <a:solidFill>
@@ -10403,7 +10759,7 @@
         <p:spPr>
           <a:xfrm>
             <a:off x="8292389" y="2724912"/>
-            <a:ext cx="3112922" cy="1845945"/>
+            <a:ext cx="3112922" cy="3401568"/>
           </a:xfrm>
           <a:prstGeom prst="rect">
             <a:avLst/>
@@ -11063,11 +11419,11 @@
         <p:spPr>
           <a:xfrm>
             <a:off x="566928" y="2231136"/>
-            <a:ext cx="5428336" cy="3073527"/>
+            <a:ext cx="5428336" cy="4059936"/>
           </a:xfrm>
           <a:prstGeom prst="roundRect">
             <a:avLst>
-              <a:gd name="adj" fmla="val 2678"/>
+              <a:gd name="adj" fmla="val 2027"/>
             </a:avLst>
           </a:prstGeom>
           <a:solidFill>
@@ -11129,7 +11485,7 @@
         <p:spPr>
           <a:xfrm>
             <a:off x="786384" y="2724912"/>
-            <a:ext cx="4989424" cy="2415159"/>
+            <a:ext cx="4989424" cy="3401568"/>
           </a:xfrm>
           <a:prstGeom prst="rect">
             <a:avLst/>
@@ -11311,11 +11667,11 @@
         <p:spPr>
           <a:xfrm>
             <a:off x="6196432" y="2231136"/>
-            <a:ext cx="5428336" cy="2384298"/>
+            <a:ext cx="5428336" cy="4059936"/>
           </a:xfrm>
           <a:prstGeom prst="roundRect">
             <a:avLst>
-              <a:gd name="adj" fmla="val 3452"/>
+              <a:gd name="adj" fmla="val 2027"/>
             </a:avLst>
           </a:prstGeom>
           <a:solidFill>
@@ -11377,7 +11733,7 @@
         <p:spPr>
           <a:xfrm>
             <a:off x="6415888" y="2724912"/>
-            <a:ext cx="4989424" cy="1725930"/>
+            <a:ext cx="4989424" cy="3401568"/>
           </a:xfrm>
           <a:prstGeom prst="rect">
             <a:avLst/>
@@ -11963,11 +12319,11 @@
         <p:spPr>
           <a:xfrm>
             <a:off x="566928" y="2231136"/>
-            <a:ext cx="3551834" cy="3533013"/>
+            <a:ext cx="3551834" cy="4059936"/>
           </a:xfrm>
           <a:prstGeom prst="roundRect">
             <a:avLst>
-              <a:gd name="adj" fmla="val 2329"/>
+              <a:gd name="adj" fmla="val 2317"/>
             </a:avLst>
           </a:prstGeom>
           <a:solidFill>
@@ -12029,7 +12385,7 @@
         <p:spPr>
           <a:xfrm>
             <a:off x="786384" y="2724912"/>
-            <a:ext cx="3112922" cy="2874645"/>
+            <a:ext cx="3112922" cy="3401568"/>
           </a:xfrm>
           <a:prstGeom prst="rect">
             <a:avLst/>
@@ -12194,11 +12550,11 @@
         <p:spPr>
           <a:xfrm>
             <a:off x="4319930" y="2231136"/>
-            <a:ext cx="3551834" cy="3533013"/>
+            <a:ext cx="3551834" cy="4059936"/>
           </a:xfrm>
           <a:prstGeom prst="roundRect">
             <a:avLst>
-              <a:gd name="adj" fmla="val 2329"/>
+              <a:gd name="adj" fmla="val 2317"/>
             </a:avLst>
           </a:prstGeom>
           <a:solidFill>
@@ -12260,7 +12616,7 @@
         <p:spPr>
           <a:xfrm>
             <a:off x="4539386" y="2724912"/>
-            <a:ext cx="3112922" cy="2874645"/>
+            <a:ext cx="3112922" cy="3401568"/>
           </a:xfrm>
           <a:prstGeom prst="rect">
             <a:avLst/>
@@ -12459,11 +12815,11 @@
         <p:spPr>
           <a:xfrm>
             <a:off x="8072933" y="2231136"/>
-            <a:ext cx="3551834" cy="2734056"/>
+            <a:ext cx="3551834" cy="4059936"/>
           </a:xfrm>
           <a:prstGeom prst="roundRect">
             <a:avLst>
-              <a:gd name="adj" fmla="val 3010"/>
+              <a:gd name="adj" fmla="val 2317"/>
             </a:avLst>
           </a:prstGeom>
           <a:solidFill>
@@ -12525,7 +12881,7 @@
         <p:spPr>
           <a:xfrm>
             <a:off x="8292389" y="2724912"/>
-            <a:ext cx="3112922" cy="2075688"/>
+            <a:ext cx="3112922" cy="3401568"/>
           </a:xfrm>
           <a:prstGeom prst="rect">
             <a:avLst/>
@@ -12836,11 +13192,11 @@
         <p:spPr>
           <a:xfrm>
             <a:off x="566928" y="2231136"/>
-            <a:ext cx="3551834" cy="3303270"/>
+            <a:ext cx="3551834" cy="4059936"/>
           </a:xfrm>
           <a:prstGeom prst="roundRect">
             <a:avLst>
-              <a:gd name="adj" fmla="val 2491"/>
+              <a:gd name="adj" fmla="val 2317"/>
             </a:avLst>
           </a:prstGeom>
           <a:solidFill>
@@ -12902,7 +13258,7 @@
         <p:spPr>
           <a:xfrm>
             <a:off x="786384" y="2724912"/>
-            <a:ext cx="3112922" cy="2644902"/>
+            <a:ext cx="3112922" cy="3401568"/>
           </a:xfrm>
           <a:prstGeom prst="rect">
             <a:avLst/>
@@ -13084,11 +13440,11 @@
         <p:spPr>
           <a:xfrm>
             <a:off x="4319930" y="2231136"/>
-            <a:ext cx="3551834" cy="3303270"/>
+            <a:ext cx="3551834" cy="4059936"/>
           </a:xfrm>
           <a:prstGeom prst="roundRect">
             <a:avLst>
-              <a:gd name="adj" fmla="val 2491"/>
+              <a:gd name="adj" fmla="val 2317"/>
             </a:avLst>
           </a:prstGeom>
           <a:solidFill>
@@ -13150,7 +13506,7 @@
         <p:spPr>
           <a:xfrm>
             <a:off x="4539386" y="2724912"/>
-            <a:ext cx="3112922" cy="2644902"/>
+            <a:ext cx="3112922" cy="3401568"/>
           </a:xfrm>
           <a:prstGeom prst="rect">
             <a:avLst/>
@@ -13298,11 +13654,11 @@
         <p:spPr>
           <a:xfrm>
             <a:off x="8072933" y="2231136"/>
-            <a:ext cx="3551834" cy="3478149"/>
+            <a:ext cx="3551834" cy="4059936"/>
           </a:xfrm>
           <a:prstGeom prst="roundRect">
             <a:avLst>
-              <a:gd name="adj" fmla="val 2366"/>
+              <a:gd name="adj" fmla="val 2317"/>
             </a:avLst>
           </a:prstGeom>
           <a:solidFill>
@@ -13364,7 +13720,7 @@
         <p:spPr>
           <a:xfrm>
             <a:off x="8292389" y="2724912"/>
-            <a:ext cx="3112922" cy="2819781"/>
+            <a:ext cx="3112922" cy="3401568"/>
           </a:xfrm>
           <a:prstGeom prst="rect">
             <a:avLst/>
@@ -13719,11 +14075,11 @@
         <p:spPr>
           <a:xfrm>
             <a:off x="566928" y="2231136"/>
-            <a:ext cx="5754319" cy="2830576"/>
+            <a:ext cx="5754319" cy="3161538"/>
           </a:xfrm>
           <a:prstGeom prst="roundRect">
             <a:avLst>
-              <a:gd name="adj" fmla="val 2907"/>
+              <a:gd name="adj" fmla="val 2603"/>
             </a:avLst>
           </a:prstGeom>
           <a:solidFill>
@@ -13785,7 +14141,7 @@
         <p:spPr>
           <a:xfrm>
             <a:off x="822960" y="2706624"/>
-            <a:ext cx="5242255" cy="2190496"/>
+            <a:ext cx="5242255" cy="2521458"/>
           </a:xfrm>
           <a:prstGeom prst="rect">
             <a:avLst/>
@@ -14222,11 +14578,11 @@
         <p:spPr>
           <a:xfrm>
             <a:off x="566928" y="1572768"/>
-            <a:ext cx="5428336" cy="2329434"/>
+            <a:ext cx="5428336" cy="4718304"/>
           </a:xfrm>
           <a:prstGeom prst="roundRect">
             <a:avLst>
-              <a:gd name="adj" fmla="val 3533"/>
+              <a:gd name="adj" fmla="val 1744"/>
             </a:avLst>
           </a:prstGeom>
           <a:solidFill>
@@ -14288,7 +14644,7 @@
         <p:spPr>
           <a:xfrm>
             <a:off x="786384" y="2066544"/>
-            <a:ext cx="4989424" cy="1671066"/>
+            <a:ext cx="4989424" cy="4059936"/>
           </a:xfrm>
           <a:prstGeom prst="rect">
             <a:avLst/>
@@ -14432,11 +14788,11 @@
         <p:spPr>
           <a:xfrm>
             <a:off x="6196432" y="1572768"/>
-            <a:ext cx="5428336" cy="2274570"/>
+            <a:ext cx="5428336" cy="4718304"/>
           </a:xfrm>
           <a:prstGeom prst="roundRect">
             <a:avLst>
-              <a:gd name="adj" fmla="val 3618"/>
+              <a:gd name="adj" fmla="val 1744"/>
             </a:avLst>
           </a:prstGeom>
           <a:solidFill>
@@ -14498,7 +14854,7 @@
         <p:spPr>
           <a:xfrm>
             <a:off x="6415888" y="2066544"/>
-            <a:ext cx="4989424" cy="1616202"/>
+            <a:ext cx="4989424" cy="4059936"/>
           </a:xfrm>
           <a:prstGeom prst="rect">
             <a:avLst/>
@@ -19041,11 +19397,11 @@
         <p:spPr>
           <a:xfrm>
             <a:off x="566928" y="2231136"/>
-            <a:ext cx="3551834" cy="2559177"/>
+            <a:ext cx="3551834" cy="4059936"/>
           </a:xfrm>
           <a:prstGeom prst="roundRect">
             <a:avLst>
-              <a:gd name="adj" fmla="val 3216"/>
+              <a:gd name="adj" fmla="val 2317"/>
             </a:avLst>
           </a:prstGeom>
           <a:solidFill>
@@ -19107,7 +19463,7 @@
         <p:spPr>
           <a:xfrm>
             <a:off x="786384" y="2724912"/>
-            <a:ext cx="3112922" cy="1900809"/>
+            <a:ext cx="3112922" cy="3401568"/>
           </a:xfrm>
           <a:prstGeom prst="rect">
             <a:avLst/>
@@ -19234,11 +19590,11 @@
         <p:spPr>
           <a:xfrm>
             <a:off x="4319930" y="2231136"/>
-            <a:ext cx="3551834" cy="3533013"/>
+            <a:ext cx="3551834" cy="4059936"/>
           </a:xfrm>
           <a:prstGeom prst="roundRect">
             <a:avLst>
-              <a:gd name="adj" fmla="val 2329"/>
+              <a:gd name="adj" fmla="val 2317"/>
             </a:avLst>
           </a:prstGeom>
           <a:solidFill>
@@ -19300,7 +19656,7 @@
         <p:spPr>
           <a:xfrm>
             <a:off x="4539386" y="2724912"/>
-            <a:ext cx="3112922" cy="2874645"/>
+            <a:ext cx="3112922" cy="3401568"/>
           </a:xfrm>
           <a:prstGeom prst="rect">
             <a:avLst/>
@@ -19448,11 +19804,11 @@
         <p:spPr>
           <a:xfrm>
             <a:off x="8072933" y="2231136"/>
-            <a:ext cx="3551834" cy="2504313"/>
+            <a:ext cx="3551834" cy="4059936"/>
           </a:xfrm>
           <a:prstGeom prst="roundRect">
             <a:avLst>
-              <a:gd name="adj" fmla="val 3286"/>
+              <a:gd name="adj" fmla="val 2317"/>
             </a:avLst>
           </a:prstGeom>
           <a:solidFill>
@@ -19514,7 +19870,7 @@
         <p:spPr>
           <a:xfrm>
             <a:off x="8292389" y="2724912"/>
-            <a:ext cx="3112922" cy="1845945"/>
+            <a:ext cx="3112922" cy="3401568"/>
           </a:xfrm>
           <a:prstGeom prst="rect">
             <a:avLst/>
@@ -20273,11 +20629,11 @@
         <p:spPr>
           <a:xfrm>
             <a:off x="566928" y="2231136"/>
-            <a:ext cx="3551834" cy="2734056"/>
+            <a:ext cx="3551834" cy="4059936"/>
           </a:xfrm>
           <a:prstGeom prst="roundRect">
             <a:avLst>
-              <a:gd name="adj" fmla="val 3010"/>
+              <a:gd name="adj" fmla="val 2317"/>
             </a:avLst>
           </a:prstGeom>
           <a:solidFill>
@@ -20339,7 +20695,7 @@
         <p:spPr>
           <a:xfrm>
             <a:off x="786384" y="2724912"/>
-            <a:ext cx="3112922" cy="2075688"/>
+            <a:ext cx="3112922" cy="3401568"/>
           </a:xfrm>
           <a:prstGeom prst="rect">
             <a:avLst/>
@@ -20496,11 +20852,11 @@
         <p:spPr>
           <a:xfrm>
             <a:off x="4319930" y="2231136"/>
-            <a:ext cx="3551834" cy="2788920"/>
+            <a:ext cx="3551834" cy="4059936"/>
           </a:xfrm>
           <a:prstGeom prst="roundRect">
             <a:avLst>
-              <a:gd name="adj" fmla="val 2951"/>
+              <a:gd name="adj" fmla="val 2317"/>
             </a:avLst>
           </a:prstGeom>
           <a:solidFill>
@@ -20562,7 +20918,7 @@
         <p:spPr>
           <a:xfrm>
             <a:off x="4539386" y="2724912"/>
-            <a:ext cx="3112922" cy="2130552"/>
+            <a:ext cx="3112922" cy="3401568"/>
           </a:xfrm>
           <a:prstGeom prst="rect">
             <a:avLst/>
@@ -20689,11 +21045,11 @@
         <p:spPr>
           <a:xfrm>
             <a:off x="8072933" y="2231136"/>
-            <a:ext cx="3551834" cy="2044827"/>
+            <a:ext cx="3551834" cy="4059936"/>
           </a:xfrm>
           <a:prstGeom prst="roundRect">
             <a:avLst>
-              <a:gd name="adj" fmla="val 4025"/>
+              <a:gd name="adj" fmla="val 2317"/>
             </a:avLst>
           </a:prstGeom>
           <a:solidFill>
@@ -20755,7 +21111,7 @@
         <p:spPr>
           <a:xfrm>
             <a:off x="8292389" y="2724912"/>
-            <a:ext cx="3112922" cy="1386459"/>
+            <a:ext cx="3112922" cy="3401568"/>
           </a:xfrm>
           <a:prstGeom prst="rect">
             <a:avLst/>
@@ -20956,7 +21312,7 @@
                 <a:ea typeface="Calibri" pitchFamily="34" charset="-122"/>
                 <a:cs typeface="Calibri" pitchFamily="34" charset="-120"/>
               </a:rPr>
-              <a:t>CLOSE</a:t>
+              <a:t>APPENDIX</a:t>
             </a:r>
             <a:endParaRPr lang="en-US" sz="1100" dirty="0"/>
           </a:p>
@@ -20995,7 +21351,7 @@
                 <a:ea typeface="Cambria" pitchFamily="34" charset="-122"/>
                 <a:cs typeface="Cambria" pitchFamily="34" charset="-120"/>
               </a:rPr>
-              <a:t>Key Takeaways</a:t>
+              <a:t>Source Decks &amp; Reference Material  (1 of 2)</a:t>
             </a:r>
             <a:endParaRPr lang="en-US" sz="3400" dirty="0"/>
           </a:p>
@@ -21009,8 +21365,8 @@
         </p:nvSpPr>
         <p:spPr>
           <a:xfrm>
-            <a:off x="566928" y="1554480"/>
-            <a:ext cx="5391760" cy="4572000"/>
+            <a:off x="566928" y="1572768"/>
+            <a:ext cx="11057839" cy="566928"/>
           </a:xfrm>
           <a:prstGeom prst="rect">
             <a:avLst/>
@@ -21026,362 +21382,967 @@
               <a:buNone/>
             </a:pPr>
             <a:r>
+              <a:rPr lang="en-US" sz="1500" dirty="0">
+                <a:solidFill>
+                  <a:srgbClr val="36454F"/>
+                </a:solidFill>
+                <a:latin typeface="Calibri" pitchFamily="34" charset="0"/>
+                <a:ea typeface="Calibri" pitchFamily="34" charset="-122"/>
+                <a:cs typeface="Calibri" pitchFamily="34" charset="-120"/>
+              </a:rPr>
+              <a:t>The existing presentations and documents this deck was built from. Open any of them to review how others have structured the same material.</a:t>
+            </a:r>
+            <a:endParaRPr lang="en-US" sz="1500" dirty="0"/>
+          </a:p>
+        </p:txBody>
+      </p:sp>
+      <p:sp>
+        <p:nvSpPr>
+          <p:cNvPr id="6" name="Shape 4"/>
+          <p:cNvSpPr/>
+          <p:nvPr/>
+        </p:nvSpPr>
+        <p:spPr>
+          <a:xfrm>
+            <a:off x="566928" y="2231136"/>
+            <a:ext cx="11057839" cy="786384"/>
+          </a:xfrm>
+          <a:prstGeom prst="roundRect">
+            <a:avLst>
+              <a:gd name="adj" fmla="val 10465"/>
+            </a:avLst>
+          </a:prstGeom>
+          <a:solidFill>
+            <a:srgbClr val="FFFFFF"/>
+          </a:solidFill>
+          <a:ln w="12700">
+            <a:solidFill>
+              <a:srgbClr val="DCE6E8"/>
+            </a:solidFill>
+            <a:prstDash val="solid"/>
+          </a:ln>
+        </p:spPr>
+      </p:sp>
+      <p:sp>
+        <p:nvSpPr>
+          <p:cNvPr id="7" name="Text 5"/>
+          <p:cNvSpPr/>
+          <p:nvPr/>
+        </p:nvSpPr>
+        <p:spPr>
+          <a:xfrm>
+            <a:off x="804672" y="2322576"/>
+            <a:ext cx="8680399" cy="256032"/>
+          </a:xfrm>
+          <a:prstGeom prst="rect">
+            <a:avLst/>
+          </a:prstGeom>
+          <a:noFill/>
+          <a:ln/>
+        </p:spPr>
+        <p:txBody>
+          <a:bodyPr wrap="square" lIns="0" tIns="0" rIns="0" bIns="0" rtlCol="0" anchor="ctr"/>
+          <a:lstStyle/>
+          <a:p>
+            <a:pPr indent="0" marL="0">
+              <a:buNone/>
+            </a:pPr>
+            <a:r>
               <a:rPr lang="en-US" sz="1300" b="1" dirty="0">
                 <a:solidFill>
+                  <a:srgbClr val="025462"/>
+                </a:solidFill>
+                <a:latin typeface="Calibri" pitchFamily="34" charset="0"/>
+                <a:ea typeface="Calibri" pitchFamily="34" charset="-122"/>
+                <a:cs typeface="Calibri" pitchFamily="34" charset="-120"/>
+              </a:rPr>
+              <a:t>ISL 2023 Consensus Document</a:t>
+            </a:r>
+            <a:endParaRPr lang="en-US" sz="1300" dirty="0"/>
+          </a:p>
+        </p:txBody>
+      </p:sp>
+      <p:sp>
+        <p:nvSpPr>
+          <p:cNvPr id="8" name="Text 6"/>
+          <p:cNvSpPr/>
+          <p:nvPr/>
+        </p:nvSpPr>
+        <p:spPr>
+          <a:xfrm>
+            <a:off x="9521647" y="2322576"/>
+            <a:ext cx="1828800" cy="256032"/>
+          </a:xfrm>
+          <a:prstGeom prst="rect">
+            <a:avLst/>
+          </a:prstGeom>
+          <a:noFill/>
+          <a:ln/>
+        </p:spPr>
+        <p:txBody>
+          <a:bodyPr wrap="square" lIns="0" tIns="0" rIns="0" bIns="0" rtlCol="0" anchor="ctr"/>
+          <a:lstStyle/>
+          <a:p>
+            <a:pPr algn="r" indent="0" marL="0">
+              <a:buNone/>
+            </a:pPr>
+            <a:r>
+              <a:rPr lang="en-US" sz="950" b="1" dirty="0">
+                <a:solidFill>
                   <a:srgbClr val="028090"/>
                 </a:solidFill>
                 <a:latin typeface="Calibri" pitchFamily="34" charset="0"/>
                 <a:ea typeface="Calibri" pitchFamily="34" charset="-122"/>
                 <a:cs typeface="Calibri" pitchFamily="34" charset="-120"/>
               </a:rPr>
-              <a:t>1.  </a:t>
-            </a:r>
+              <a:t>PDF · primary source</a:t>
+            </a:r>
+            <a:endParaRPr lang="en-US" sz="950" dirty="0"/>
+          </a:p>
+        </p:txBody>
+      </p:sp>
+      <p:sp>
+        <p:nvSpPr>
+          <p:cNvPr id="9" name="Text 7"/>
+          <p:cNvSpPr/>
+          <p:nvPr/>
+        </p:nvSpPr>
+        <p:spPr>
+          <a:xfrm>
+            <a:off x="804672" y="2560320"/>
+            <a:ext cx="10582351" cy="201168"/>
+          </a:xfrm>
+          <a:prstGeom prst="rect">
+            <a:avLst/>
+          </a:prstGeom>
+          <a:noFill/>
+          <a:ln/>
+        </p:spPr>
+        <p:txBody>
+          <a:bodyPr wrap="square" lIns="0" tIns="0" rIns="0" bIns="0" rtlCol="0" anchor="ctr"/>
+          <a:lstStyle/>
+          <a:p>
             <a:pPr indent="0" marL="0">
-              <a:spcAft>
-                <a:spcPts val="900"/>
-              </a:spcAft>
-              <a:buNone/>
-            </a:pPr>
-            <a:r>
-              <a:rPr lang="en-US" sz="1300" dirty="0">
-                <a:solidFill>
-                  <a:srgbClr val="1B2A30"/>
-                </a:solidFill>
-                <a:latin typeface="Calibri" pitchFamily="34" charset="0"/>
-                <a:ea typeface="Calibri" pitchFamily="34" charset="-122"/>
-                <a:cs typeface="Calibri" pitchFamily="34" charset="-120"/>
-              </a:rPr>
-              <a:t>Lymphedema is mechanical insufficiency — high-protein, progressive, and self-reinforcing if untreated.</a:t>
+              <a:buNone/>
+            </a:pPr>
+            <a:r>
+              <a:rPr lang="en-US" sz="1050" dirty="0">
+                <a:solidFill>
+                  <a:srgbClr val="36454F"/>
+                </a:solidFill>
+                <a:latin typeface="Calibri" pitchFamily="34" charset="0"/>
+                <a:ea typeface="Calibri" pitchFamily="34" charset="-122"/>
+                <a:cs typeface="Calibri" pitchFamily="34" charset="-120"/>
+              </a:rPr>
+              <a:t>The staging authority. Stages 0–III, diagnosis, and treatment.</a:t>
+            </a:r>
+            <a:endParaRPr lang="en-US" sz="1050" dirty="0"/>
+          </a:p>
+        </p:txBody>
+      </p:sp>
+      <p:sp>
+        <p:nvSpPr>
+          <p:cNvPr id="10" name="Text 8"/>
+          <p:cNvSpPr/>
+          <p:nvPr/>
+        </p:nvSpPr>
+        <p:spPr>
+          <a:xfrm>
+            <a:off x="804672" y="2761488"/>
+            <a:ext cx="10582351" cy="201168"/>
+          </a:xfrm>
+          <a:prstGeom prst="rect">
+            <a:avLst/>
+          </a:prstGeom>
+          <a:noFill/>
+          <a:ln/>
+        </p:spPr>
+        <p:txBody>
+          <a:bodyPr wrap="square" lIns="0" tIns="0" rIns="0" bIns="0" rtlCol="0" anchor="ctr"/>
+          <a:lstStyle/>
+          <a:p>
+            <a:pPr indent="0" marL="0">
+              <a:buNone/>
+            </a:pPr>
+            <a:r>
+              <a:rPr lang="en-US" sz="850" u="sng" dirty="0">
+                <a:solidFill>
+                  <a:srgbClr val="1C7293"/>
+                </a:solidFill>
+                <a:latin typeface="Calibri" pitchFamily="34" charset="0"/>
+                <a:ea typeface="Calibri" pitchFamily="34" charset="-122"/>
+                <a:cs typeface="Calibri" pitchFamily="34" charset="-120"/>
+                <a:hlinkClick r:id="rId1" invalidUrl="" action="" tgtFrame="" tooltip="" history="1" highlightClick="0" endSnd="0">
+                  <a:extLst>
+                    <a:ext uri="{A12FA001-AC4F-418D-AE19-62706E023703}">
+                      <ahyp:hlinkClr xmlns:ahyp="http://schemas.microsoft.com/office/drawing/2018/hyperlinkcolor" val="tx"/>
+                    </a:ext>
+                  </a:extLst>
+                </a:hlinkClick>
+              </a:rPr>
+              <a:t>https://www.isl.arizona.edu/sites/default/files/2024-11/THE-DIAGNOSIS-AND-TREATMENT-OF-PERIPHERAL-LYMPHEDEMA-2023-CONSENSUS-DOCUMENT-OF-THE-INTERNATIONAL-SOCIETY-OF-LYMPHOLOGY.pdf</a:t>
+            </a:r>
+            <a:endParaRPr lang="en-US" sz="850" dirty="0"/>
+          </a:p>
+        </p:txBody>
+      </p:sp>
+      <p:sp>
+        <p:nvSpPr>
+          <p:cNvPr id="11" name="Shape 9"/>
+          <p:cNvSpPr/>
+          <p:nvPr/>
+        </p:nvSpPr>
+        <p:spPr>
+          <a:xfrm>
+            <a:off x="566928" y="3127248"/>
+            <a:ext cx="11057839" cy="786384"/>
+          </a:xfrm>
+          <a:prstGeom prst="roundRect">
+            <a:avLst>
+              <a:gd name="adj" fmla="val 10465"/>
+            </a:avLst>
+          </a:prstGeom>
+          <a:solidFill>
+            <a:srgbClr val="FFFFFF"/>
+          </a:solidFill>
+          <a:ln w="12700">
+            <a:solidFill>
+              <a:srgbClr val="DCE6E8"/>
+            </a:solidFill>
+            <a:prstDash val="solid"/>
+          </a:ln>
+        </p:spPr>
+      </p:sp>
+      <p:sp>
+        <p:nvSpPr>
+          <p:cNvPr id="12" name="Text 10"/>
+          <p:cNvSpPr/>
+          <p:nvPr/>
+        </p:nvSpPr>
+        <p:spPr>
+          <a:xfrm>
+            <a:off x="804672" y="3218688"/>
+            <a:ext cx="8680399" cy="256032"/>
+          </a:xfrm>
+          <a:prstGeom prst="rect">
+            <a:avLst/>
+          </a:prstGeom>
+          <a:noFill/>
+          <a:ln/>
+        </p:spPr>
+        <p:txBody>
+          <a:bodyPr wrap="square" lIns="0" tIns="0" rIns="0" bIns="0" rtlCol="0" anchor="ctr"/>
+          <a:lstStyle/>
+          <a:p>
+            <a:pPr indent="0" marL="0">
+              <a:buNone/>
+            </a:pPr>
+            <a:r>
+              <a:rPr lang="en-US" sz="1300" b="1" dirty="0">
+                <a:solidFill>
+                  <a:srgbClr val="025462"/>
+                </a:solidFill>
+                <a:latin typeface="Calibri" pitchFamily="34" charset="0"/>
+                <a:ea typeface="Calibri" pitchFamily="34" charset="-122"/>
+                <a:cs typeface="Calibri" pitchFamily="34" charset="-120"/>
+              </a:rPr>
+              <a:t>Linda Koehler, PT, CLT-LANA — Univ. of Minnesota</a:t>
             </a:r>
             <a:endParaRPr lang="en-US" sz="1300" dirty="0"/>
           </a:p>
+        </p:txBody>
+      </p:sp>
+      <p:sp>
+        <p:nvSpPr>
+          <p:cNvPr id="13" name="Text 11"/>
+          <p:cNvSpPr/>
+          <p:nvPr/>
+        </p:nvSpPr>
+        <p:spPr>
+          <a:xfrm>
+            <a:off x="9521647" y="3218688"/>
+            <a:ext cx="1828800" cy="256032"/>
+          </a:xfrm>
+          <a:prstGeom prst="rect">
+            <a:avLst/>
+          </a:prstGeom>
+          <a:noFill/>
+          <a:ln/>
+        </p:spPr>
+        <p:txBody>
+          <a:bodyPr wrap="square" lIns="0" tIns="0" rIns="0" bIns="0" rtlCol="0" anchor="ctr"/>
+          <a:lstStyle/>
+          <a:p>
+            <a:pPr algn="r" indent="0" marL="0">
+              <a:buNone/>
+            </a:pPr>
+            <a:r>
+              <a:rPr lang="en-US" sz="950" b="1" dirty="0">
+                <a:solidFill>
+                  <a:srgbClr val="028090"/>
+                </a:solidFill>
+                <a:latin typeface="Calibri" pitchFamily="34" charset="0"/>
+                <a:ea typeface="Calibri" pitchFamily="34" charset="-122"/>
+                <a:cs typeface="Calibri" pitchFamily="34" charset="-120"/>
+              </a:rPr>
+              <a:t>Slide deck</a:t>
+            </a:r>
+            <a:endParaRPr lang="en-US" sz="950" dirty="0"/>
+          </a:p>
+        </p:txBody>
+      </p:sp>
+      <p:sp>
+        <p:nvSpPr>
+          <p:cNvPr id="14" name="Text 12"/>
+          <p:cNvSpPr/>
+          <p:nvPr/>
+        </p:nvSpPr>
+        <p:spPr>
+          <a:xfrm>
+            <a:off x="804672" y="3456432"/>
+            <a:ext cx="10582351" cy="201168"/>
+          </a:xfrm>
+          <a:prstGeom prst="rect">
+            <a:avLst/>
+          </a:prstGeom>
+          <a:noFill/>
+          <a:ln/>
+        </p:spPr>
+        <p:txBody>
+          <a:bodyPr wrap="square" lIns="0" tIns="0" rIns="0" bIns="0" rtlCol="0" anchor="ctr"/>
+          <a:lstStyle/>
           <a:p>
             <a:pPr indent="0" marL="0">
               <a:buNone/>
             </a:pPr>
             <a:r>
+              <a:rPr lang="en-US" sz="1050" dirty="0">
+                <a:solidFill>
+                  <a:srgbClr val="36454F"/>
+                </a:solidFill>
+                <a:latin typeface="Calibri" pitchFamily="34" charset="0"/>
+                <a:ea typeface="Calibri" pitchFamily="34" charset="-122"/>
+                <a:cs typeface="Calibri" pitchFamily="34" charset="-120"/>
+              </a:rPr>
+              <a:t>Best PT-focused deck found. CDT components, wound care, pain management.</a:t>
+            </a:r>
+            <a:endParaRPr lang="en-US" sz="1050" dirty="0"/>
+          </a:p>
+        </p:txBody>
+      </p:sp>
+      <p:sp>
+        <p:nvSpPr>
+          <p:cNvPr id="15" name="Text 13"/>
+          <p:cNvSpPr/>
+          <p:nvPr/>
+        </p:nvSpPr>
+        <p:spPr>
+          <a:xfrm>
+            <a:off x="804672" y="3657600"/>
+            <a:ext cx="10582351" cy="201168"/>
+          </a:xfrm>
+          <a:prstGeom prst="rect">
+            <a:avLst/>
+          </a:prstGeom>
+          <a:noFill/>
+          <a:ln/>
+        </p:spPr>
+        <p:txBody>
+          <a:bodyPr wrap="square" lIns="0" tIns="0" rIns="0" bIns="0" rtlCol="0" anchor="ctr"/>
+          <a:lstStyle/>
+          <a:p>
+            <a:pPr indent="0" marL="0">
+              <a:buNone/>
+            </a:pPr>
+            <a:r>
+              <a:rPr lang="en-US" sz="850" u="sng" dirty="0">
+                <a:solidFill>
+                  <a:srgbClr val="1C7293"/>
+                </a:solidFill>
+                <a:latin typeface="Calibri" pitchFamily="34" charset="0"/>
+                <a:ea typeface="Calibri" pitchFamily="34" charset="-122"/>
+                <a:cs typeface="Calibri" pitchFamily="34" charset="-120"/>
+                <a:hlinkClick r:id="rId2" invalidUrl="" action="" tgtFrame="" tooltip="" history="1" highlightClick="0" endSnd="0">
+                  <a:extLst>
+                    <a:ext uri="{A12FA001-AC4F-418D-AE19-62706E023703}">
+                      <ahyp:hlinkClr xmlns:ahyp="http://schemas.microsoft.com/office/drawing/2018/hyperlinkcolor" val="tx"/>
+                    </a:ext>
+                  </a:extLst>
+                </a:hlinkClick>
+              </a:rPr>
+              <a:t>https://www.slideserve.com/collin/lymphedema-overview-and-treatment-considerations</a:t>
+            </a:r>
+            <a:endParaRPr lang="en-US" sz="850" dirty="0"/>
+          </a:p>
+        </p:txBody>
+      </p:sp>
+      <p:sp>
+        <p:nvSpPr>
+          <p:cNvPr id="16" name="Shape 14"/>
+          <p:cNvSpPr/>
+          <p:nvPr/>
+        </p:nvSpPr>
+        <p:spPr>
+          <a:xfrm>
+            <a:off x="566928" y="4023360"/>
+            <a:ext cx="11057839" cy="786384"/>
+          </a:xfrm>
+          <a:prstGeom prst="roundRect">
+            <a:avLst>
+              <a:gd name="adj" fmla="val 10465"/>
+            </a:avLst>
+          </a:prstGeom>
+          <a:solidFill>
+            <a:srgbClr val="FFFFFF"/>
+          </a:solidFill>
+          <a:ln w="12700">
+            <a:solidFill>
+              <a:srgbClr val="DCE6E8"/>
+            </a:solidFill>
+            <a:prstDash val="solid"/>
+          </a:ln>
+        </p:spPr>
+      </p:sp>
+      <p:sp>
+        <p:nvSpPr>
+          <p:cNvPr id="17" name="Text 15"/>
+          <p:cNvSpPr/>
+          <p:nvPr/>
+        </p:nvSpPr>
+        <p:spPr>
+          <a:xfrm>
+            <a:off x="804672" y="4114800"/>
+            <a:ext cx="8680399" cy="256032"/>
+          </a:xfrm>
+          <a:prstGeom prst="rect">
+            <a:avLst/>
+          </a:prstGeom>
+          <a:noFill/>
+          <a:ln/>
+        </p:spPr>
+        <p:txBody>
+          <a:bodyPr wrap="square" lIns="0" tIns="0" rIns="0" bIns="0" rtlCol="0" anchor="ctr"/>
+          <a:lstStyle/>
+          <a:p>
+            <a:pPr indent="0" marL="0">
+              <a:buNone/>
+            </a:pPr>
+            <a:r>
               <a:rPr lang="en-US" sz="1300" b="1" dirty="0">
                 <a:solidFill>
+                  <a:srgbClr val="025462"/>
+                </a:solidFill>
+                <a:latin typeface="Calibri" pitchFamily="34" charset="0"/>
+                <a:ea typeface="Calibri" pitchFamily="34" charset="-122"/>
+                <a:cs typeface="Calibri" pitchFamily="34" charset="-120"/>
+              </a:rPr>
+              <a:t>Christina Hankins, PT, CLT, CWS — Lymphedema</a:t>
+            </a:r>
+            <a:endParaRPr lang="en-US" sz="1300" dirty="0"/>
+          </a:p>
+        </p:txBody>
+      </p:sp>
+      <p:sp>
+        <p:nvSpPr>
+          <p:cNvPr id="18" name="Text 16"/>
+          <p:cNvSpPr/>
+          <p:nvPr/>
+        </p:nvSpPr>
+        <p:spPr>
+          <a:xfrm>
+            <a:off x="9521647" y="4114800"/>
+            <a:ext cx="1828800" cy="256032"/>
+          </a:xfrm>
+          <a:prstGeom prst="rect">
+            <a:avLst/>
+          </a:prstGeom>
+          <a:noFill/>
+          <a:ln/>
+        </p:spPr>
+        <p:txBody>
+          <a:bodyPr wrap="square" lIns="0" tIns="0" rIns="0" bIns="0" rtlCol="0" anchor="ctr"/>
+          <a:lstStyle/>
+          <a:p>
+            <a:pPr algn="r" indent="0" marL="0">
+              <a:buNone/>
+            </a:pPr>
+            <a:r>
+              <a:rPr lang="en-US" sz="950" b="1" dirty="0">
+                <a:solidFill>
                   <a:srgbClr val="028090"/>
                 </a:solidFill>
                 <a:latin typeface="Calibri" pitchFamily="34" charset="0"/>
                 <a:ea typeface="Calibri" pitchFamily="34" charset="-122"/>
                 <a:cs typeface="Calibri" pitchFamily="34" charset="-120"/>
               </a:rPr>
-              <a:t>2.  </a:t>
-            </a:r>
+              <a:t>Slide deck</a:t>
+            </a:r>
+            <a:endParaRPr lang="en-US" sz="950" dirty="0"/>
+          </a:p>
+        </p:txBody>
+      </p:sp>
+      <p:sp>
+        <p:nvSpPr>
+          <p:cNvPr id="19" name="Text 17"/>
+          <p:cNvSpPr/>
+          <p:nvPr/>
+        </p:nvSpPr>
+        <p:spPr>
+          <a:xfrm>
+            <a:off x="804672" y="4352544"/>
+            <a:ext cx="10582351" cy="201168"/>
+          </a:xfrm>
+          <a:prstGeom prst="rect">
+            <a:avLst/>
+          </a:prstGeom>
+          <a:noFill/>
+          <a:ln/>
+        </p:spPr>
+        <p:txBody>
+          <a:bodyPr wrap="square" lIns="0" tIns="0" rIns="0" bIns="0" rtlCol="0" anchor="ctr"/>
+          <a:lstStyle/>
+          <a:p>
             <a:pPr indent="0" marL="0">
-              <a:spcAft>
-                <a:spcPts val="900"/>
-              </a:spcAft>
-              <a:buNone/>
-            </a:pPr>
-            <a:r>
-              <a:rPr lang="en-US" sz="1300" dirty="0">
-                <a:solidFill>
-                  <a:srgbClr val="1B2A30"/>
-                </a:solidFill>
-                <a:latin typeface="Calibri" pitchFamily="34" charset="0"/>
-                <a:ea typeface="Calibri" pitchFamily="34" charset="-122"/>
-                <a:cs typeface="Calibri" pitchFamily="34" charset="-120"/>
-              </a:rPr>
-              <a:t>Symptoms precede visible swelling. Stage 0 is real and is the best time to intervene.</a:t>
+              <a:buNone/>
+            </a:pPr>
+            <a:r>
+              <a:rPr lang="en-US" sz="1050" dirty="0">
+                <a:solidFill>
+                  <a:srgbClr val="36454F"/>
+                </a:solidFill>
+                <a:latin typeface="Calibri" pitchFamily="34" charset="0"/>
+                <a:ea typeface="Calibri" pitchFamily="34" charset="-122"/>
+                <a:cs typeface="Calibri" pitchFamily="34" charset="-120"/>
+              </a:rPr>
+              <a:t>Good objectives and outline structure to model.</a:t>
+            </a:r>
+            <a:endParaRPr lang="en-US" sz="1050" dirty="0"/>
+          </a:p>
+        </p:txBody>
+      </p:sp>
+      <p:sp>
+        <p:nvSpPr>
+          <p:cNvPr id="20" name="Text 18"/>
+          <p:cNvSpPr/>
+          <p:nvPr/>
+        </p:nvSpPr>
+        <p:spPr>
+          <a:xfrm>
+            <a:off x="804672" y="4553712"/>
+            <a:ext cx="10582351" cy="201168"/>
+          </a:xfrm>
+          <a:prstGeom prst="rect">
+            <a:avLst/>
+          </a:prstGeom>
+          <a:noFill/>
+          <a:ln/>
+        </p:spPr>
+        <p:txBody>
+          <a:bodyPr wrap="square" lIns="0" tIns="0" rIns="0" bIns="0" rtlCol="0" anchor="ctr"/>
+          <a:lstStyle/>
+          <a:p>
+            <a:pPr indent="0" marL="0">
+              <a:buNone/>
+            </a:pPr>
+            <a:r>
+              <a:rPr lang="en-US" sz="850" u="sng" dirty="0">
+                <a:solidFill>
+                  <a:srgbClr val="1C7293"/>
+                </a:solidFill>
+                <a:latin typeface="Calibri" pitchFamily="34" charset="0"/>
+                <a:ea typeface="Calibri" pitchFamily="34" charset="-122"/>
+                <a:cs typeface="Calibri" pitchFamily="34" charset="-120"/>
+                <a:hlinkClick r:id="rId3" invalidUrl="" action="" tgtFrame="" tooltip="" history="1" highlightClick="0" endSnd="0">
+                  <a:extLst>
+                    <a:ext uri="{A12FA001-AC4F-418D-AE19-62706E023703}">
+                      <ahyp:hlinkClr xmlns:ahyp="http://schemas.microsoft.com/office/drawing/2018/hyperlinkcolor" val="tx"/>
+                    </a:ext>
+                  </a:extLst>
+                </a:hlinkClick>
+              </a:rPr>
+              <a:t>https://www.slideserve.com/lilly/lymphedema</a:t>
+            </a:r>
+            <a:endParaRPr lang="en-US" sz="850" dirty="0"/>
+          </a:p>
+        </p:txBody>
+      </p:sp>
+      <p:sp>
+        <p:nvSpPr>
+          <p:cNvPr id="21" name="Shape 19"/>
+          <p:cNvSpPr/>
+          <p:nvPr/>
+        </p:nvSpPr>
+        <p:spPr>
+          <a:xfrm>
+            <a:off x="566928" y="4919472"/>
+            <a:ext cx="11057839" cy="786384"/>
+          </a:xfrm>
+          <a:prstGeom prst="roundRect">
+            <a:avLst>
+              <a:gd name="adj" fmla="val 10465"/>
+            </a:avLst>
+          </a:prstGeom>
+          <a:solidFill>
+            <a:srgbClr val="FFFFFF"/>
+          </a:solidFill>
+          <a:ln w="12700">
+            <a:solidFill>
+              <a:srgbClr val="DCE6E8"/>
+            </a:solidFill>
+            <a:prstDash val="solid"/>
+          </a:ln>
+        </p:spPr>
+      </p:sp>
+      <p:sp>
+        <p:nvSpPr>
+          <p:cNvPr id="22" name="Text 20"/>
+          <p:cNvSpPr/>
+          <p:nvPr/>
+        </p:nvSpPr>
+        <p:spPr>
+          <a:xfrm>
+            <a:off x="804672" y="5010912"/>
+            <a:ext cx="8680399" cy="256032"/>
+          </a:xfrm>
+          <a:prstGeom prst="rect">
+            <a:avLst/>
+          </a:prstGeom>
+          <a:noFill/>
+          <a:ln/>
+        </p:spPr>
+        <p:txBody>
+          <a:bodyPr wrap="square" lIns="0" tIns="0" rIns="0" bIns="0" rtlCol="0" anchor="ctr"/>
+          <a:lstStyle/>
+          <a:p>
+            <a:pPr indent="0" marL="0">
+              <a:buNone/>
+            </a:pPr>
+            <a:r>
+              <a:rPr lang="en-US" sz="1300" b="1" dirty="0">
+                <a:solidFill>
+                  <a:srgbClr val="025462"/>
+                </a:solidFill>
+                <a:latin typeface="Calibri" pitchFamily="34" charset="0"/>
+                <a:ea typeface="Calibri" pitchFamily="34" charset="-122"/>
+                <a:cs typeface="Calibri" pitchFamily="34" charset="-120"/>
+              </a:rPr>
+              <a:t>Lymphedema Therapy (compiled decks)</a:t>
             </a:r>
             <a:endParaRPr lang="en-US" sz="1300" dirty="0"/>
           </a:p>
+        </p:txBody>
+      </p:sp>
+      <p:sp>
+        <p:nvSpPr>
+          <p:cNvPr id="23" name="Text 21"/>
+          <p:cNvSpPr/>
+          <p:nvPr/>
+        </p:nvSpPr>
+        <p:spPr>
+          <a:xfrm>
+            <a:off x="9521647" y="5010912"/>
+            <a:ext cx="1828800" cy="256032"/>
+          </a:xfrm>
+          <a:prstGeom prst="rect">
+            <a:avLst/>
+          </a:prstGeom>
+          <a:noFill/>
+          <a:ln/>
+        </p:spPr>
+        <p:txBody>
+          <a:bodyPr wrap="square" lIns="0" tIns="0" rIns="0" bIns="0" rtlCol="0" anchor="ctr"/>
+          <a:lstStyle/>
+          <a:p>
+            <a:pPr algn="r" indent="0" marL="0">
+              <a:buNone/>
+            </a:pPr>
+            <a:r>
+              <a:rPr lang="en-US" sz="950" b="1" dirty="0">
+                <a:solidFill>
+                  <a:srgbClr val="028090"/>
+                </a:solidFill>
+                <a:latin typeface="Calibri" pitchFamily="34" charset="0"/>
+                <a:ea typeface="Calibri" pitchFamily="34" charset="-122"/>
+                <a:cs typeface="Calibri" pitchFamily="34" charset="-120"/>
+              </a:rPr>
+              <a:t>Slide deck</a:t>
+            </a:r>
+            <a:endParaRPr lang="en-US" sz="950" dirty="0"/>
+          </a:p>
+        </p:txBody>
+      </p:sp>
+      <p:sp>
+        <p:nvSpPr>
+          <p:cNvPr id="24" name="Text 22"/>
+          <p:cNvSpPr/>
+          <p:nvPr/>
+        </p:nvSpPr>
+        <p:spPr>
+          <a:xfrm>
+            <a:off x="804672" y="5248656"/>
+            <a:ext cx="10582351" cy="201168"/>
+          </a:xfrm>
+          <a:prstGeom prst="rect">
+            <a:avLst/>
+          </a:prstGeom>
+          <a:noFill/>
+          <a:ln/>
+        </p:spPr>
+        <p:txBody>
+          <a:bodyPr wrap="square" lIns="0" tIns="0" rIns="0" bIns="0" rtlCol="0" anchor="ctr"/>
+          <a:lstStyle/>
           <a:p>
             <a:pPr indent="0" marL="0">
               <a:buNone/>
             </a:pPr>
             <a:r>
+              <a:rPr lang="en-US" sz="1050" dirty="0">
+                <a:solidFill>
+                  <a:srgbClr val="36454F"/>
+                </a:solidFill>
+                <a:latin typeface="Calibri" pitchFamily="34" charset="0"/>
+                <a:ea typeface="Calibri" pitchFamily="34" charset="-122"/>
+                <a:cs typeface="Calibri" pitchFamily="34" charset="-120"/>
+              </a:rPr>
+              <a:t>Several decks on one page, incl. stage descriptions and exercise evidence.</a:t>
+            </a:r>
+            <a:endParaRPr lang="en-US" sz="1050" dirty="0"/>
+          </a:p>
+        </p:txBody>
+      </p:sp>
+      <p:sp>
+        <p:nvSpPr>
+          <p:cNvPr id="25" name="Text 23"/>
+          <p:cNvSpPr/>
+          <p:nvPr/>
+        </p:nvSpPr>
+        <p:spPr>
+          <a:xfrm>
+            <a:off x="804672" y="5449824"/>
+            <a:ext cx="10582351" cy="201168"/>
+          </a:xfrm>
+          <a:prstGeom prst="rect">
+            <a:avLst/>
+          </a:prstGeom>
+          <a:noFill/>
+          <a:ln/>
+        </p:spPr>
+        <p:txBody>
+          <a:bodyPr wrap="square" lIns="0" tIns="0" rIns="0" bIns="0" rtlCol="0" anchor="ctr"/>
+          <a:lstStyle/>
+          <a:p>
+            <a:pPr indent="0" marL="0">
+              <a:buNone/>
+            </a:pPr>
+            <a:r>
+              <a:rPr lang="en-US" sz="850" u="sng" dirty="0">
+                <a:solidFill>
+                  <a:srgbClr val="1C7293"/>
+                </a:solidFill>
+                <a:latin typeface="Calibri" pitchFamily="34" charset="0"/>
+                <a:ea typeface="Calibri" pitchFamily="34" charset="-122"/>
+                <a:cs typeface="Calibri" pitchFamily="34" charset="-120"/>
+                <a:hlinkClick r:id="rId4" invalidUrl="" action="" tgtFrame="" tooltip="" history="1" highlightClick="0" endSnd="0">
+                  <a:extLst>
+                    <a:ext uri="{A12FA001-AC4F-418D-AE19-62706E023703}">
+                      <ahyp:hlinkClr xmlns:ahyp="http://schemas.microsoft.com/office/drawing/2018/hyperlinkcolor" val="tx"/>
+                    </a:ext>
+                  </a:extLst>
+                </a:hlinkClick>
+              </a:rPr>
+              <a:t>https://www.slideserve.com/lael/lymphedema-therapy</a:t>
+            </a:r>
+            <a:endParaRPr lang="en-US" sz="850" dirty="0"/>
+          </a:p>
+        </p:txBody>
+      </p:sp>
+      <p:sp>
+        <p:nvSpPr>
+          <p:cNvPr id="26" name="Shape 24"/>
+          <p:cNvSpPr/>
+          <p:nvPr/>
+        </p:nvSpPr>
+        <p:spPr>
+          <a:xfrm>
+            <a:off x="566928" y="5815584"/>
+            <a:ext cx="11057839" cy="786384"/>
+          </a:xfrm>
+          <a:prstGeom prst="roundRect">
+            <a:avLst>
+              <a:gd name="adj" fmla="val 10465"/>
+            </a:avLst>
+          </a:prstGeom>
+          <a:solidFill>
+            <a:srgbClr val="FFFFFF"/>
+          </a:solidFill>
+          <a:ln w="12700">
+            <a:solidFill>
+              <a:srgbClr val="DCE6E8"/>
+            </a:solidFill>
+            <a:prstDash val="solid"/>
+          </a:ln>
+        </p:spPr>
+      </p:sp>
+      <p:sp>
+        <p:nvSpPr>
+          <p:cNvPr id="27" name="Text 25"/>
+          <p:cNvSpPr/>
+          <p:nvPr/>
+        </p:nvSpPr>
+        <p:spPr>
+          <a:xfrm>
+            <a:off x="804672" y="5907024"/>
+            <a:ext cx="8680399" cy="256032"/>
+          </a:xfrm>
+          <a:prstGeom prst="rect">
+            <a:avLst/>
+          </a:prstGeom>
+          <a:noFill/>
+          <a:ln/>
+        </p:spPr>
+        <p:txBody>
+          <a:bodyPr wrap="square" lIns="0" tIns="0" rIns="0" bIns="0" rtlCol="0" anchor="ctr"/>
+          <a:lstStyle/>
+          <a:p>
+            <a:pPr indent="0" marL="0">
+              <a:buNone/>
+            </a:pPr>
+            <a:r>
               <a:rPr lang="en-US" sz="1300" b="1" dirty="0">
                 <a:solidFill>
+                  <a:srgbClr val="025462"/>
+                </a:solidFill>
+                <a:latin typeface="Calibri" pitchFamily="34" charset="0"/>
+                <a:ea typeface="Calibri" pitchFamily="34" charset="-122"/>
+                <a:cs typeface="Calibri" pitchFamily="34" charset="-120"/>
+              </a:rPr>
+              <a:t>Lymphedema — assorted author decks</a:t>
+            </a:r>
+            <a:endParaRPr lang="en-US" sz="1300" dirty="0"/>
+          </a:p>
+        </p:txBody>
+      </p:sp>
+      <p:sp>
+        <p:nvSpPr>
+          <p:cNvPr id="28" name="Text 26"/>
+          <p:cNvSpPr/>
+          <p:nvPr/>
+        </p:nvSpPr>
+        <p:spPr>
+          <a:xfrm>
+            <a:off x="9521647" y="5907024"/>
+            <a:ext cx="1828800" cy="256032"/>
+          </a:xfrm>
+          <a:prstGeom prst="rect">
+            <a:avLst/>
+          </a:prstGeom>
+          <a:noFill/>
+          <a:ln/>
+        </p:spPr>
+        <p:txBody>
+          <a:bodyPr wrap="square" lIns="0" tIns="0" rIns="0" bIns="0" rtlCol="0" anchor="ctr"/>
+          <a:lstStyle/>
+          <a:p>
+            <a:pPr algn="r" indent="0" marL="0">
+              <a:buNone/>
+            </a:pPr>
+            <a:r>
+              <a:rPr lang="en-US" sz="950" b="1" dirty="0">
+                <a:solidFill>
                   <a:srgbClr val="028090"/>
                 </a:solidFill>
                 <a:latin typeface="Calibri" pitchFamily="34" charset="0"/>
                 <a:ea typeface="Calibri" pitchFamily="34" charset="-122"/>
                 <a:cs typeface="Calibri" pitchFamily="34" charset="-120"/>
               </a:rPr>
-              <a:t>3.  </a:t>
-            </a:r>
+              <a:t>Slide deck</a:t>
+            </a:r>
+            <a:endParaRPr lang="en-US" sz="950" dirty="0"/>
+          </a:p>
+        </p:txBody>
+      </p:sp>
+      <p:sp>
+        <p:nvSpPr>
+          <p:cNvPr id="29" name="Text 27"/>
+          <p:cNvSpPr/>
+          <p:nvPr/>
+        </p:nvSpPr>
+        <p:spPr>
+          <a:xfrm>
+            <a:off x="804672" y="6144768"/>
+            <a:ext cx="10582351" cy="201168"/>
+          </a:xfrm>
+          <a:prstGeom prst="rect">
+            <a:avLst/>
+          </a:prstGeom>
+          <a:noFill/>
+          <a:ln/>
+        </p:spPr>
+        <p:txBody>
+          <a:bodyPr wrap="square" lIns="0" tIns="0" rIns="0" bIns="0" rtlCol="0" anchor="ctr"/>
+          <a:lstStyle/>
+          <a:p>
             <a:pPr indent="0" marL="0">
-              <a:spcAft>
-                <a:spcPts val="900"/>
-              </a:spcAft>
-              <a:buNone/>
-            </a:pPr>
-            <a:r>
-              <a:rPr lang="en-US" sz="1300" dirty="0">
-                <a:solidFill>
-                  <a:srgbClr val="1B2A30"/>
-                </a:solidFill>
-                <a:latin typeface="Calibri" pitchFamily="34" charset="0"/>
-                <a:ea typeface="Calibri" pitchFamily="34" charset="-122"/>
-                <a:cs typeface="Calibri" pitchFamily="34" charset="-120"/>
-              </a:rPr>
-              <a:t>Stemmer's sign is fast, free, and diagnostic when positive.</a:t>
-            </a:r>
-            <a:endParaRPr lang="en-US" sz="1300" dirty="0"/>
-          </a:p>
+              <a:buNone/>
+            </a:pPr>
+            <a:r>
+              <a:rPr lang="en-US" sz="1050" dirty="0">
+                <a:solidFill>
+                  <a:srgbClr val="36454F"/>
+                </a:solidFill>
+                <a:latin typeface="Calibri" pitchFamily="34" charset="0"/>
+                <a:ea typeface="Calibri" pitchFamily="34" charset="-122"/>
+                <a:cs typeface="Calibri" pitchFamily="34" charset="-120"/>
+              </a:rPr>
+              <a:t>Ernandez, Richter, Arslan, Johansson. Mixed quality; useful for framing.</a:t>
+            </a:r>
+            <a:endParaRPr lang="en-US" sz="1050" dirty="0"/>
+          </a:p>
+        </p:txBody>
+      </p:sp>
+      <p:sp>
+        <p:nvSpPr>
+          <p:cNvPr id="30" name="Text 28"/>
+          <p:cNvSpPr/>
+          <p:nvPr/>
+        </p:nvSpPr>
+        <p:spPr>
+          <a:xfrm>
+            <a:off x="804672" y="6345936"/>
+            <a:ext cx="10582351" cy="201168"/>
+          </a:xfrm>
+          <a:prstGeom prst="rect">
+            <a:avLst/>
+          </a:prstGeom>
+          <a:noFill/>
+          <a:ln/>
+        </p:spPr>
+        <p:txBody>
+          <a:bodyPr wrap="square" lIns="0" tIns="0" rIns="0" bIns="0" rtlCol="0" anchor="ctr"/>
+          <a:lstStyle/>
           <a:p>
             <a:pPr indent="0" marL="0">
               <a:buNone/>
             </a:pPr>
             <a:r>
-              <a:rPr lang="en-US" sz="1300" b="1" dirty="0">
-                <a:solidFill>
-                  <a:srgbClr val="028090"/>
-                </a:solidFill>
-                <a:latin typeface="Calibri" pitchFamily="34" charset="0"/>
-                <a:ea typeface="Calibri" pitchFamily="34" charset="-122"/>
-                <a:cs typeface="Calibri" pitchFamily="34" charset="-120"/>
-              </a:rPr>
-              <a:t>4.  </a:t>
-            </a:r>
-            <a:pPr indent="0" marL="0">
-              <a:spcAft>
-                <a:spcPts val="900"/>
-              </a:spcAft>
-              <a:buNone/>
-            </a:pPr>
-            <a:r>
-              <a:rPr lang="en-US" sz="1300" dirty="0">
-                <a:solidFill>
-                  <a:srgbClr val="1B2A30"/>
-                </a:solidFill>
-                <a:latin typeface="Calibri" pitchFamily="34" charset="0"/>
-                <a:ea typeface="Calibri" pitchFamily="34" charset="-122"/>
-                <a:cs typeface="Calibri" pitchFamily="34" charset="-120"/>
-              </a:rPr>
-              <a:t>Four ISL stages: 0 latent, I reversible, II irreversible/fibrotic, III elephantiasis.</a:t>
-            </a:r>
-            <a:endParaRPr lang="en-US" sz="1300" dirty="0"/>
-          </a:p>
-          <a:p>
-            <a:pPr indent="0" marL="0">
-              <a:buNone/>
-            </a:pPr>
-            <a:r>
-              <a:rPr lang="en-US" sz="1300" b="1" dirty="0">
-                <a:solidFill>
-                  <a:srgbClr val="028090"/>
-                </a:solidFill>
-                <a:latin typeface="Calibri" pitchFamily="34" charset="0"/>
-                <a:ea typeface="Calibri" pitchFamily="34" charset="-122"/>
-                <a:cs typeface="Calibri" pitchFamily="34" charset="-120"/>
-              </a:rPr>
-              <a:t>5.  </a:t>
-            </a:r>
-            <a:pPr indent="0" marL="0">
-              <a:spcAft>
-                <a:spcPts val="900"/>
-              </a:spcAft>
-              <a:buNone/>
-            </a:pPr>
-            <a:r>
-              <a:rPr lang="en-US" sz="1300" dirty="0">
-                <a:solidFill>
-                  <a:srgbClr val="1B2A30"/>
-                </a:solidFill>
-                <a:latin typeface="Calibri" pitchFamily="34" charset="0"/>
-                <a:ea typeface="Calibri" pitchFamily="34" charset="-122"/>
-                <a:cs typeface="Calibri" pitchFamily="34" charset="-120"/>
-              </a:rPr>
-              <a:t>CDT has four components. Compression is the one that holds the result.</a:t>
-            </a:r>
-            <a:endParaRPr lang="en-US" sz="1300" dirty="0"/>
-          </a:p>
-        </p:txBody>
-      </p:sp>
-      <p:sp>
-        <p:nvSpPr>
-          <p:cNvPr id="6" name="Text 4"/>
-          <p:cNvSpPr/>
-          <p:nvPr/>
-        </p:nvSpPr>
-        <p:spPr>
-          <a:xfrm>
-            <a:off x="6233008" y="1554480"/>
-            <a:ext cx="5391760" cy="4572000"/>
-          </a:xfrm>
-          <a:prstGeom prst="rect">
-            <a:avLst/>
-          </a:prstGeom>
-          <a:noFill/>
-          <a:ln/>
-        </p:spPr>
-        <p:txBody>
-          <a:bodyPr wrap="square" lIns="0" tIns="0" rIns="0" bIns="0" rtlCol="0" anchor="t"/>
-          <a:lstStyle/>
-          <a:p>
-            <a:pPr indent="0" marL="0">
-              <a:buNone/>
-            </a:pPr>
-            <a:r>
-              <a:rPr lang="en-US" sz="1300" b="1" dirty="0">
-                <a:solidFill>
-                  <a:srgbClr val="028090"/>
-                </a:solidFill>
-                <a:latin typeface="Calibri" pitchFamily="34" charset="0"/>
-                <a:ea typeface="Calibri" pitchFamily="34" charset="-122"/>
-                <a:cs typeface="Calibri" pitchFamily="34" charset="-120"/>
-              </a:rPr>
-              <a:t>6.  </a:t>
-            </a:r>
-            <a:pPr indent="0" marL="0">
-              <a:spcAft>
-                <a:spcPts val="900"/>
-              </a:spcAft>
-              <a:buNone/>
-            </a:pPr>
-            <a:r>
-              <a:rPr lang="en-US" sz="1300" dirty="0">
-                <a:solidFill>
-                  <a:srgbClr val="1B2A30"/>
-                </a:solidFill>
-                <a:latin typeface="Calibri" pitchFamily="34" charset="0"/>
-                <a:ea typeface="Calibri" pitchFamily="34" charset="-122"/>
-                <a:cs typeface="Calibri" pitchFamily="34" charset="-120"/>
-              </a:rPr>
-              <a:t>Exercise under compression is treatment. Resistance training is safe.</a:t>
-            </a:r>
-            <a:endParaRPr lang="en-US" sz="1300" dirty="0"/>
-          </a:p>
-          <a:p>
-            <a:pPr indent="0" marL="0">
-              <a:buNone/>
-            </a:pPr>
-            <a:r>
-              <a:rPr lang="en-US" sz="1300" b="1" dirty="0">
-                <a:solidFill>
-                  <a:srgbClr val="028090"/>
-                </a:solidFill>
-                <a:latin typeface="Calibri" pitchFamily="34" charset="0"/>
-                <a:ea typeface="Calibri" pitchFamily="34" charset="-122"/>
-                <a:cs typeface="Calibri" pitchFamily="34" charset="-120"/>
-              </a:rPr>
-              <a:t>7.  </a:t>
-            </a:r>
-            <a:pPr indent="0" marL="0">
-              <a:spcAft>
-                <a:spcPts val="900"/>
-              </a:spcAft>
-              <a:buNone/>
-            </a:pPr>
-            <a:r>
-              <a:rPr lang="en-US" sz="1300" dirty="0">
-                <a:solidFill>
-                  <a:srgbClr val="1B2A30"/>
-                </a:solidFill>
-                <a:latin typeface="Calibri" pitchFamily="34" charset="0"/>
-                <a:ea typeface="Calibri" pitchFamily="34" charset="-122"/>
-                <a:cs typeface="Calibri" pitchFamily="34" charset="-120"/>
-              </a:rPr>
-              <a:t>Lipedema is painful, symmetrical, spares the feet, and has a negative Stemmer.</a:t>
-            </a:r>
-            <a:endParaRPr lang="en-US" sz="1300" dirty="0"/>
-          </a:p>
-          <a:p>
-            <a:pPr indent="0" marL="0">
-              <a:buNone/>
-            </a:pPr>
-            <a:r>
-              <a:rPr lang="en-US" sz="1300" b="1" dirty="0">
-                <a:solidFill>
-                  <a:srgbClr val="028090"/>
-                </a:solidFill>
-                <a:latin typeface="Calibri" pitchFamily="34" charset="0"/>
-                <a:ea typeface="Calibri" pitchFamily="34" charset="-122"/>
-                <a:cs typeface="Calibri" pitchFamily="34" charset="-120"/>
-              </a:rPr>
-              <a:t>8.  </a:t>
-            </a:r>
-            <a:pPr indent="0" marL="0">
-              <a:spcAft>
-                <a:spcPts val="900"/>
-              </a:spcAft>
-              <a:buNone/>
-            </a:pPr>
-            <a:r>
-              <a:rPr lang="en-US" sz="1300" dirty="0">
-                <a:solidFill>
-                  <a:srgbClr val="1B2A30"/>
-                </a:solidFill>
-                <a:latin typeface="Calibri" pitchFamily="34" charset="0"/>
-                <a:ea typeface="Calibri" pitchFamily="34" charset="-122"/>
-                <a:cs typeface="Calibri" pitchFamily="34" charset="-120"/>
-              </a:rPr>
-              <a:t>Lipedema is staged 1–3, with lipo-lymphedema as a contested Stage 4.</a:t>
-            </a:r>
-            <a:endParaRPr lang="en-US" sz="1300" dirty="0"/>
-          </a:p>
-          <a:p>
-            <a:pPr indent="0" marL="0">
-              <a:buNone/>
-            </a:pPr>
-            <a:r>
-              <a:rPr lang="en-US" sz="1300" b="1" dirty="0">
-                <a:solidFill>
-                  <a:srgbClr val="028090"/>
-                </a:solidFill>
-                <a:latin typeface="Calibri" pitchFamily="34" charset="0"/>
-                <a:ea typeface="Calibri" pitchFamily="34" charset="-122"/>
-                <a:cs typeface="Calibri" pitchFamily="34" charset="-120"/>
-              </a:rPr>
-              <a:t>9.  </a:t>
-            </a:r>
-            <a:pPr indent="0" marL="0">
-              <a:spcAft>
-                <a:spcPts val="900"/>
-              </a:spcAft>
-              <a:buNone/>
-            </a:pPr>
-            <a:r>
-              <a:rPr lang="en-US" sz="1300" dirty="0">
-                <a:solidFill>
-                  <a:srgbClr val="1B2A30"/>
-                </a:solidFill>
-                <a:latin typeface="Calibri" pitchFamily="34" charset="0"/>
-                <a:ea typeface="Calibri" pitchFamily="34" charset="-122"/>
-                <a:cs typeface="Calibri" pitchFamily="34" charset="-120"/>
-              </a:rPr>
-              <a:t>Every episode of cellulitis makes the underlying disease worse.</a:t>
-            </a:r>
-            <a:endParaRPr lang="en-US" sz="1300" dirty="0"/>
-          </a:p>
-          <a:p>
-            <a:pPr indent="0" marL="0">
-              <a:buNone/>
-            </a:pPr>
-            <a:r>
-              <a:rPr lang="en-US" sz="1300" b="1" dirty="0">
-                <a:solidFill>
-                  <a:srgbClr val="028090"/>
-                </a:solidFill>
-                <a:latin typeface="Calibri" pitchFamily="34" charset="0"/>
-                <a:ea typeface="Calibri" pitchFamily="34" charset="-122"/>
-                <a:cs typeface="Calibri" pitchFamily="34" charset="-120"/>
-              </a:rPr>
-              <a:t>10.  </a:t>
-            </a:r>
-            <a:pPr indent="0" marL="0">
-              <a:spcAft>
-                <a:spcPts val="900"/>
-              </a:spcAft>
-              <a:buNone/>
-            </a:pPr>
-            <a:r>
-              <a:rPr lang="en-US" sz="1300" dirty="0">
-                <a:solidFill>
-                  <a:srgbClr val="1B2A30"/>
-                </a:solidFill>
-                <a:latin typeface="Calibri" pitchFamily="34" charset="0"/>
-                <a:ea typeface="Calibri" pitchFamily="34" charset="-122"/>
-                <a:cs typeface="Calibri" pitchFamily="34" charset="-120"/>
-              </a:rPr>
-              <a:t>Patient education and Phase II adherence determine long-term outcome.</a:t>
-            </a:r>
-            <a:endParaRPr lang="en-US" sz="1300" dirty="0"/>
+              <a:rPr lang="en-US" sz="850" u="sng" dirty="0">
+                <a:solidFill>
+                  <a:srgbClr val="1C7293"/>
+                </a:solidFill>
+                <a:latin typeface="Calibri" pitchFamily="34" charset="0"/>
+                <a:ea typeface="Calibri" pitchFamily="34" charset="-122"/>
+                <a:cs typeface="Calibri" pitchFamily="34" charset="-120"/>
+                <a:hlinkClick r:id="rId5" invalidUrl="" action="" tgtFrame="" tooltip="" history="1" highlightClick="0" endSnd="0">
+                  <a:extLst>
+                    <a:ext uri="{A12FA001-AC4F-418D-AE19-62706E023703}">
+                      <ahyp:hlinkClr xmlns:ahyp="http://schemas.microsoft.com/office/drawing/2018/hyperlinkcolor" val="tx"/>
+                    </a:ext>
+                  </a:extLst>
+                </a:hlinkClick>
+              </a:rPr>
+              <a:t>https://www.slideserve.com/shoshana-reynolds/lymphedema-powerpoint-ppt-presentation</a:t>
+            </a:r>
+            <a:endParaRPr lang="en-US" sz="850" dirty="0"/>
           </a:p>
         </p:txBody>
       </p:sp>
@@ -21396,6 +22357,1638 @@
 <file path=ppt/slides/slide32.xml><?xml version="1.0" encoding="utf-8"?>
 <p:sld xmlns:a="http://schemas.openxmlformats.org/drawingml/2006/main" xmlns:r="http://schemas.openxmlformats.org/officeDocument/2006/relationships" xmlns:p="http://schemas.openxmlformats.org/presentationml/2006/main">
   <p:cSld name="Slide 32">
+    <p:bg>
+      <p:bgPr>
+        <a:solidFill>
+          <a:srgbClr val="F4F8F9"/>
+        </a:solidFill>
+      </p:bgPr>
+    </p:bg>
+    <p:spTree>
+      <p:nvGrpSpPr>
+        <p:cNvPr id="1" name=""/>
+        <p:cNvGrpSpPr/>
+        <p:nvPr/>
+      </p:nvGrpSpPr>
+      <p:grpSpPr>
+        <a:xfrm>
+          <a:off x="0" y="0"/>
+          <a:ext cx="0" cy="0"/>
+          <a:chOff x="0" y="0"/>
+          <a:chExt cx="0" cy="0"/>
+        </a:xfrm>
+      </p:grpSpPr>
+      <p:sp>
+        <p:nvSpPr>
+          <p:cNvPr id="2" name="Text 0"/>
+          <p:cNvSpPr/>
+          <p:nvPr/>
+        </p:nvSpPr>
+        <p:spPr>
+          <a:xfrm>
+            <a:off x="11414455" y="6382512"/>
+            <a:ext cx="457200" cy="274320"/>
+          </a:xfrm>
+          <a:prstGeom prst="rect">
+            <a:avLst/>
+          </a:prstGeom>
+          <a:noFill/>
+          <a:ln/>
+        </p:spPr>
+        <p:txBody>
+          <a:bodyPr wrap="square" lIns="0" tIns="0" rIns="0" bIns="0" rtlCol="0" anchor="ctr"/>
+          <a:lstStyle/>
+          <a:p>
+            <a:pPr algn="r" indent="0" marL="0">
+              <a:buNone/>
+            </a:pPr>
+            <a:r>
+              <a:rPr lang="en-US" sz="1000" dirty="0">
+                <a:solidFill>
+                  <a:srgbClr val="9BB0B8"/>
+                </a:solidFill>
+                <a:latin typeface="Calibri" pitchFamily="34" charset="0"/>
+                <a:ea typeface="Calibri" pitchFamily="34" charset="-122"/>
+                <a:cs typeface="Calibri" pitchFamily="34" charset="-120"/>
+              </a:rPr>
+              <a:t>32</a:t>
+            </a:r>
+            <a:endParaRPr lang="en-US" sz="1000" dirty="0"/>
+          </a:p>
+        </p:txBody>
+      </p:sp>
+      <p:sp>
+        <p:nvSpPr>
+          <p:cNvPr id="3" name="Text 1"/>
+          <p:cNvSpPr/>
+          <p:nvPr/>
+        </p:nvSpPr>
+        <p:spPr>
+          <a:xfrm>
+            <a:off x="566928" y="310896"/>
+            <a:ext cx="11057839" cy="274320"/>
+          </a:xfrm>
+          <a:prstGeom prst="rect">
+            <a:avLst/>
+          </a:prstGeom>
+          <a:noFill/>
+          <a:ln/>
+        </p:spPr>
+        <p:txBody>
+          <a:bodyPr wrap="square" lIns="0" tIns="0" rIns="0" bIns="0" rtlCol="0" anchor="ctr"/>
+          <a:lstStyle/>
+          <a:p>
+            <a:pPr indent="0" marL="0">
+              <a:buNone/>
+            </a:pPr>
+            <a:r>
+              <a:rPr lang="en-US" sz="1100" b="1" spc="200" kern="0" dirty="0">
+                <a:solidFill>
+                  <a:srgbClr val="028090"/>
+                </a:solidFill>
+                <a:latin typeface="Calibri" pitchFamily="34" charset="0"/>
+                <a:ea typeface="Calibri" pitchFamily="34" charset="-122"/>
+                <a:cs typeface="Calibri" pitchFamily="34" charset="-120"/>
+              </a:rPr>
+              <a:t>APPENDIX</a:t>
+            </a:r>
+            <a:endParaRPr lang="en-US" sz="1100" dirty="0"/>
+          </a:p>
+        </p:txBody>
+      </p:sp>
+      <p:sp>
+        <p:nvSpPr>
+          <p:cNvPr id="4" name="Text 2"/>
+          <p:cNvSpPr/>
+          <p:nvPr/>
+        </p:nvSpPr>
+        <p:spPr>
+          <a:xfrm>
+            <a:off x="566928" y="603504"/>
+            <a:ext cx="11057839" cy="777240"/>
+          </a:xfrm>
+          <a:prstGeom prst="rect">
+            <a:avLst/>
+          </a:prstGeom>
+          <a:noFill/>
+          <a:ln/>
+        </p:spPr>
+        <p:txBody>
+          <a:bodyPr wrap="square" lIns="0" tIns="0" rIns="0" bIns="0" rtlCol="0" anchor="t"/>
+          <a:lstStyle/>
+          <a:p>
+            <a:pPr indent="0" marL="0">
+              <a:buNone/>
+            </a:pPr>
+            <a:r>
+              <a:rPr lang="en-US" sz="3400" b="1" dirty="0">
+                <a:solidFill>
+                  <a:srgbClr val="025462"/>
+                </a:solidFill>
+                <a:latin typeface="Cambria" pitchFamily="34" charset="0"/>
+                <a:ea typeface="Cambria" pitchFamily="34" charset="-122"/>
+                <a:cs typeface="Cambria" pitchFamily="34" charset="-120"/>
+              </a:rPr>
+              <a:t>Source Decks &amp; Reference Material  (2 of 2)</a:t>
+            </a:r>
+            <a:endParaRPr lang="en-US" sz="3400" dirty="0"/>
+          </a:p>
+        </p:txBody>
+      </p:sp>
+      <p:sp>
+        <p:nvSpPr>
+          <p:cNvPr id="5" name="Shape 3"/>
+          <p:cNvSpPr/>
+          <p:nvPr/>
+        </p:nvSpPr>
+        <p:spPr>
+          <a:xfrm>
+            <a:off x="566928" y="1691640"/>
+            <a:ext cx="11057839" cy="786384"/>
+          </a:xfrm>
+          <a:prstGeom prst="roundRect">
+            <a:avLst>
+              <a:gd name="adj" fmla="val 10465"/>
+            </a:avLst>
+          </a:prstGeom>
+          <a:solidFill>
+            <a:srgbClr val="FFFFFF"/>
+          </a:solidFill>
+          <a:ln w="12700">
+            <a:solidFill>
+              <a:srgbClr val="DCE6E8"/>
+            </a:solidFill>
+            <a:prstDash val="solid"/>
+          </a:ln>
+        </p:spPr>
+      </p:sp>
+      <p:sp>
+        <p:nvSpPr>
+          <p:cNvPr id="6" name="Text 4"/>
+          <p:cNvSpPr/>
+          <p:nvPr/>
+        </p:nvSpPr>
+        <p:spPr>
+          <a:xfrm>
+            <a:off x="804672" y="1783080"/>
+            <a:ext cx="8680399" cy="256032"/>
+          </a:xfrm>
+          <a:prstGeom prst="rect">
+            <a:avLst/>
+          </a:prstGeom>
+          <a:noFill/>
+          <a:ln/>
+        </p:spPr>
+        <p:txBody>
+          <a:bodyPr wrap="square" lIns="0" tIns="0" rIns="0" bIns="0" rtlCol="0" anchor="ctr"/>
+          <a:lstStyle/>
+          <a:p>
+            <a:pPr indent="0" marL="0">
+              <a:buNone/>
+            </a:pPr>
+            <a:r>
+              <a:rPr lang="en-US" sz="1300" b="1" dirty="0">
+                <a:solidFill>
+                  <a:srgbClr val="025462"/>
+                </a:solidFill>
+                <a:latin typeface="Calibri" pitchFamily="34" charset="0"/>
+                <a:ea typeface="Calibri" pitchFamily="34" charset="-122"/>
+                <a:cs typeface="Calibri" pitchFamily="34" charset="-120"/>
+              </a:rPr>
+              <a:t>Clinical Outcomes After PT for Secondary Lymphedema</a:t>
+            </a:r>
+            <a:endParaRPr lang="en-US" sz="1300" dirty="0"/>
+          </a:p>
+        </p:txBody>
+      </p:sp>
+      <p:sp>
+        <p:nvSpPr>
+          <p:cNvPr id="7" name="Text 5"/>
+          <p:cNvSpPr/>
+          <p:nvPr/>
+        </p:nvSpPr>
+        <p:spPr>
+          <a:xfrm>
+            <a:off x="9521647" y="1783080"/>
+            <a:ext cx="1828800" cy="256032"/>
+          </a:xfrm>
+          <a:prstGeom prst="rect">
+            <a:avLst/>
+          </a:prstGeom>
+          <a:noFill/>
+          <a:ln/>
+        </p:spPr>
+        <p:txBody>
+          <a:bodyPr wrap="square" lIns="0" tIns="0" rIns="0" bIns="0" rtlCol="0" anchor="ctr"/>
+          <a:lstStyle/>
+          <a:p>
+            <a:pPr algn="r" indent="0" marL="0">
+              <a:buNone/>
+            </a:pPr>
+            <a:r>
+              <a:rPr lang="en-US" sz="950" b="1" dirty="0">
+                <a:solidFill>
+                  <a:srgbClr val="028090"/>
+                </a:solidFill>
+                <a:latin typeface="Calibri" pitchFamily="34" charset="0"/>
+                <a:ea typeface="Calibri" pitchFamily="34" charset="-122"/>
+                <a:cs typeface="Calibri" pitchFamily="34" charset="-120"/>
+              </a:rPr>
+              <a:t>Case report</a:t>
+            </a:r>
+            <a:endParaRPr lang="en-US" sz="950" dirty="0"/>
+          </a:p>
+        </p:txBody>
+      </p:sp>
+      <p:sp>
+        <p:nvSpPr>
+          <p:cNvPr id="8" name="Text 6"/>
+          <p:cNvSpPr/>
+          <p:nvPr/>
+        </p:nvSpPr>
+        <p:spPr>
+          <a:xfrm>
+            <a:off x="804672" y="2020824"/>
+            <a:ext cx="10582351" cy="201168"/>
+          </a:xfrm>
+          <a:prstGeom prst="rect">
+            <a:avLst/>
+          </a:prstGeom>
+          <a:noFill/>
+          <a:ln/>
+        </p:spPr>
+        <p:txBody>
+          <a:bodyPr wrap="square" lIns="0" tIns="0" rIns="0" bIns="0" rtlCol="0" anchor="ctr"/>
+          <a:lstStyle/>
+          <a:p>
+            <a:pPr indent="0" marL="0">
+              <a:buNone/>
+            </a:pPr>
+            <a:r>
+              <a:rPr lang="en-US" sz="1050" dirty="0">
+                <a:solidFill>
+                  <a:srgbClr val="36454F"/>
+                </a:solidFill>
+                <a:latin typeface="Calibri" pitchFamily="34" charset="0"/>
+                <a:ea typeface="Calibri" pitchFamily="34" charset="-122"/>
+                <a:cs typeface="Calibri" pitchFamily="34" charset="-120"/>
+              </a:rPr>
+              <a:t>Zuther &amp; Norton staging language in plain English.</a:t>
+            </a:r>
+            <a:endParaRPr lang="en-US" sz="1050" dirty="0"/>
+          </a:p>
+        </p:txBody>
+      </p:sp>
+      <p:sp>
+        <p:nvSpPr>
+          <p:cNvPr id="9" name="Text 7"/>
+          <p:cNvSpPr/>
+          <p:nvPr/>
+        </p:nvSpPr>
+        <p:spPr>
+          <a:xfrm>
+            <a:off x="804672" y="2221992"/>
+            <a:ext cx="10582351" cy="201168"/>
+          </a:xfrm>
+          <a:prstGeom prst="rect">
+            <a:avLst/>
+          </a:prstGeom>
+          <a:noFill/>
+          <a:ln/>
+        </p:spPr>
+        <p:txBody>
+          <a:bodyPr wrap="square" lIns="0" tIns="0" rIns="0" bIns="0" rtlCol="0" anchor="ctr"/>
+          <a:lstStyle/>
+          <a:p>
+            <a:pPr indent="0" marL="0">
+              <a:buNone/>
+            </a:pPr>
+            <a:r>
+              <a:rPr lang="en-US" sz="850" u="sng" dirty="0">
+                <a:solidFill>
+                  <a:srgbClr val="1C7293"/>
+                </a:solidFill>
+                <a:latin typeface="Calibri" pitchFamily="34" charset="0"/>
+                <a:ea typeface="Calibri" pitchFamily="34" charset="-122"/>
+                <a:cs typeface="Calibri" pitchFamily="34" charset="-120"/>
+                <a:hlinkClick r:id="rId1" invalidUrl="" action="" tgtFrame="" tooltip="" history="1" highlightClick="0" endSnd="0">
+                  <a:extLst>
+                    <a:ext uri="{A12FA001-AC4F-418D-AE19-62706E023703}">
+                      <ahyp:hlinkClr xmlns:ahyp="http://schemas.microsoft.com/office/drawing/2018/hyperlinkcolor" val="tx"/>
+                    </a:ext>
+                  </a:extLst>
+                </a:hlinkClick>
+              </a:rPr>
+              <a:t>https://www.ncbi.nlm.nih.gov/pmc/articles/PMC6666846/</a:t>
+            </a:r>
+            <a:endParaRPr lang="en-US" sz="850" dirty="0"/>
+          </a:p>
+        </p:txBody>
+      </p:sp>
+      <p:sp>
+        <p:nvSpPr>
+          <p:cNvPr id="10" name="Shape 8"/>
+          <p:cNvSpPr/>
+          <p:nvPr/>
+        </p:nvSpPr>
+        <p:spPr>
+          <a:xfrm>
+            <a:off x="566928" y="2587752"/>
+            <a:ext cx="11057839" cy="786384"/>
+          </a:xfrm>
+          <a:prstGeom prst="roundRect">
+            <a:avLst>
+              <a:gd name="adj" fmla="val 10465"/>
+            </a:avLst>
+          </a:prstGeom>
+          <a:solidFill>
+            <a:srgbClr val="FFFFFF"/>
+          </a:solidFill>
+          <a:ln w="12700">
+            <a:solidFill>
+              <a:srgbClr val="DCE6E8"/>
+            </a:solidFill>
+            <a:prstDash val="solid"/>
+          </a:ln>
+        </p:spPr>
+      </p:sp>
+      <p:sp>
+        <p:nvSpPr>
+          <p:cNvPr id="11" name="Text 9"/>
+          <p:cNvSpPr/>
+          <p:nvPr/>
+        </p:nvSpPr>
+        <p:spPr>
+          <a:xfrm>
+            <a:off x="804672" y="2679192"/>
+            <a:ext cx="8680399" cy="256032"/>
+          </a:xfrm>
+          <a:prstGeom prst="rect">
+            <a:avLst/>
+          </a:prstGeom>
+          <a:noFill/>
+          <a:ln/>
+        </p:spPr>
+        <p:txBody>
+          <a:bodyPr wrap="square" lIns="0" tIns="0" rIns="0" bIns="0" rtlCol="0" anchor="ctr"/>
+          <a:lstStyle/>
+          <a:p>
+            <a:pPr indent="0" marL="0">
+              <a:buNone/>
+            </a:pPr>
+            <a:r>
+              <a:rPr lang="en-US" sz="1300" b="1" dirty="0">
+                <a:solidFill>
+                  <a:srgbClr val="025462"/>
+                </a:solidFill>
+                <a:latin typeface="Calibri" pitchFamily="34" charset="0"/>
+                <a:ea typeface="Calibri" pitchFamily="34" charset="-122"/>
+                <a:cs typeface="Calibri" pitchFamily="34" charset="-120"/>
+              </a:rPr>
+              <a:t>Lipedema Foundation — Staging</a:t>
+            </a:r>
+            <a:endParaRPr lang="en-US" sz="1300" dirty="0"/>
+          </a:p>
+        </p:txBody>
+      </p:sp>
+      <p:sp>
+        <p:nvSpPr>
+          <p:cNvPr id="12" name="Text 10"/>
+          <p:cNvSpPr/>
+          <p:nvPr/>
+        </p:nvSpPr>
+        <p:spPr>
+          <a:xfrm>
+            <a:off x="9521647" y="2679192"/>
+            <a:ext cx="1828800" cy="256032"/>
+          </a:xfrm>
+          <a:prstGeom prst="rect">
+            <a:avLst/>
+          </a:prstGeom>
+          <a:noFill/>
+          <a:ln/>
+        </p:spPr>
+        <p:txBody>
+          <a:bodyPr wrap="square" lIns="0" tIns="0" rIns="0" bIns="0" rtlCol="0" anchor="ctr"/>
+          <a:lstStyle/>
+          <a:p>
+            <a:pPr algn="r" indent="0" marL="0">
+              <a:buNone/>
+            </a:pPr>
+            <a:r>
+              <a:rPr lang="en-US" sz="950" b="1" dirty="0">
+                <a:solidFill>
+                  <a:srgbClr val="028090"/>
+                </a:solidFill>
+                <a:latin typeface="Calibri" pitchFamily="34" charset="0"/>
+                <a:ea typeface="Calibri" pitchFamily="34" charset="-122"/>
+                <a:cs typeface="Calibri" pitchFamily="34" charset="-120"/>
+              </a:rPr>
+              <a:t>Reference + photos</a:t>
+            </a:r>
+            <a:endParaRPr lang="en-US" sz="950" dirty="0"/>
+          </a:p>
+        </p:txBody>
+      </p:sp>
+      <p:sp>
+        <p:nvSpPr>
+          <p:cNvPr id="13" name="Text 11"/>
+          <p:cNvSpPr/>
+          <p:nvPr/>
+        </p:nvSpPr>
+        <p:spPr>
+          <a:xfrm>
+            <a:off x="804672" y="2916936"/>
+            <a:ext cx="10582351" cy="201168"/>
+          </a:xfrm>
+          <a:prstGeom prst="rect">
+            <a:avLst/>
+          </a:prstGeom>
+          <a:noFill/>
+          <a:ln/>
+        </p:spPr>
+        <p:txBody>
+          <a:bodyPr wrap="square" lIns="0" tIns="0" rIns="0" bIns="0" rtlCol="0" anchor="ctr"/>
+          <a:lstStyle/>
+          <a:p>
+            <a:pPr indent="0" marL="0">
+              <a:buNone/>
+            </a:pPr>
+            <a:r>
+              <a:rPr lang="en-US" sz="1050" dirty="0">
+                <a:solidFill>
+                  <a:srgbClr val="36454F"/>
+                </a:solidFill>
+                <a:latin typeface="Calibri" pitchFamily="34" charset="0"/>
+                <a:ea typeface="Calibri" pitchFamily="34" charset="-122"/>
+                <a:cs typeface="Calibri" pitchFamily="34" charset="-120"/>
+              </a:rPr>
+              <a:t>Best lipedema staging photos. Note: they no longer use “Stage 4”.</a:t>
+            </a:r>
+            <a:endParaRPr lang="en-US" sz="1050" dirty="0"/>
+          </a:p>
+        </p:txBody>
+      </p:sp>
+      <p:sp>
+        <p:nvSpPr>
+          <p:cNvPr id="14" name="Text 12"/>
+          <p:cNvSpPr/>
+          <p:nvPr/>
+        </p:nvSpPr>
+        <p:spPr>
+          <a:xfrm>
+            <a:off x="804672" y="3118104"/>
+            <a:ext cx="10582351" cy="201168"/>
+          </a:xfrm>
+          <a:prstGeom prst="rect">
+            <a:avLst/>
+          </a:prstGeom>
+          <a:noFill/>
+          <a:ln/>
+        </p:spPr>
+        <p:txBody>
+          <a:bodyPr wrap="square" lIns="0" tIns="0" rIns="0" bIns="0" rtlCol="0" anchor="ctr"/>
+          <a:lstStyle/>
+          <a:p>
+            <a:pPr indent="0" marL="0">
+              <a:buNone/>
+            </a:pPr>
+            <a:r>
+              <a:rPr lang="en-US" sz="850" u="sng" dirty="0">
+                <a:solidFill>
+                  <a:srgbClr val="1C7293"/>
+                </a:solidFill>
+                <a:latin typeface="Calibri" pitchFamily="34" charset="0"/>
+                <a:ea typeface="Calibri" pitchFamily="34" charset="-122"/>
+                <a:cs typeface="Calibri" pitchFamily="34" charset="-120"/>
+                <a:hlinkClick r:id="rId2" invalidUrl="" action="" tgtFrame="" tooltip="" history="1" highlightClick="0" endSnd="0">
+                  <a:extLst>
+                    <a:ext uri="{A12FA001-AC4F-418D-AE19-62706E023703}">
+                      <ahyp:hlinkClr xmlns:ahyp="http://schemas.microsoft.com/office/drawing/2018/hyperlinkcolor" val="tx"/>
+                    </a:ext>
+                  </a:extLst>
+                </a:hlinkClick>
+              </a:rPr>
+              <a:t>https://www.lipedema.org/staging</a:t>
+            </a:r>
+            <a:endParaRPr lang="en-US" sz="850" dirty="0"/>
+          </a:p>
+        </p:txBody>
+      </p:sp>
+      <p:sp>
+        <p:nvSpPr>
+          <p:cNvPr id="15" name="Shape 13"/>
+          <p:cNvSpPr/>
+          <p:nvPr/>
+        </p:nvSpPr>
+        <p:spPr>
+          <a:xfrm>
+            <a:off x="566928" y="3483864"/>
+            <a:ext cx="11057839" cy="786384"/>
+          </a:xfrm>
+          <a:prstGeom prst="roundRect">
+            <a:avLst>
+              <a:gd name="adj" fmla="val 10465"/>
+            </a:avLst>
+          </a:prstGeom>
+          <a:solidFill>
+            <a:srgbClr val="FFFFFF"/>
+          </a:solidFill>
+          <a:ln w="12700">
+            <a:solidFill>
+              <a:srgbClr val="DCE6E8"/>
+            </a:solidFill>
+            <a:prstDash val="solid"/>
+          </a:ln>
+        </p:spPr>
+      </p:sp>
+      <p:sp>
+        <p:nvSpPr>
+          <p:cNvPr id="16" name="Text 14"/>
+          <p:cNvSpPr/>
+          <p:nvPr/>
+        </p:nvSpPr>
+        <p:spPr>
+          <a:xfrm>
+            <a:off x="804672" y="3575304"/>
+            <a:ext cx="8680399" cy="256032"/>
+          </a:xfrm>
+          <a:prstGeom prst="rect">
+            <a:avLst/>
+          </a:prstGeom>
+          <a:noFill/>
+          <a:ln/>
+        </p:spPr>
+        <p:txBody>
+          <a:bodyPr wrap="square" lIns="0" tIns="0" rIns="0" bIns="0" rtlCol="0" anchor="ctr"/>
+          <a:lstStyle/>
+          <a:p>
+            <a:pPr indent="0" marL="0">
+              <a:buNone/>
+            </a:pPr>
+            <a:r>
+              <a:rPr lang="en-US" sz="1300" b="1" dirty="0">
+                <a:solidFill>
+                  <a:srgbClr val="025462"/>
+                </a:solidFill>
+                <a:latin typeface="Calibri" pitchFamily="34" charset="0"/>
+                <a:ea typeface="Calibri" pitchFamily="34" charset="-122"/>
+                <a:cs typeface="Calibri" pitchFamily="34" charset="-120"/>
+              </a:rPr>
+              <a:t>Understanding Stage 4 Lipedema: Lipo-Lymphedema</a:t>
+            </a:r>
+            <a:endParaRPr lang="en-US" sz="1300" dirty="0"/>
+          </a:p>
+        </p:txBody>
+      </p:sp>
+      <p:sp>
+        <p:nvSpPr>
+          <p:cNvPr id="17" name="Text 15"/>
+          <p:cNvSpPr/>
+          <p:nvPr/>
+        </p:nvSpPr>
+        <p:spPr>
+          <a:xfrm>
+            <a:off x="9521647" y="3575304"/>
+            <a:ext cx="1828800" cy="256032"/>
+          </a:xfrm>
+          <a:prstGeom prst="rect">
+            <a:avLst/>
+          </a:prstGeom>
+          <a:noFill/>
+          <a:ln/>
+        </p:spPr>
+        <p:txBody>
+          <a:bodyPr wrap="square" lIns="0" tIns="0" rIns="0" bIns="0" rtlCol="0" anchor="ctr"/>
+          <a:lstStyle/>
+          <a:p>
+            <a:pPr algn="r" indent="0" marL="0">
+              <a:buNone/>
+            </a:pPr>
+            <a:r>
+              <a:rPr lang="en-US" sz="950" b="1" dirty="0">
+                <a:solidFill>
+                  <a:srgbClr val="028090"/>
+                </a:solidFill>
+                <a:latin typeface="Calibri" pitchFamily="34" charset="0"/>
+                <a:ea typeface="Calibri" pitchFamily="34" charset="-122"/>
+                <a:cs typeface="Calibri" pitchFamily="34" charset="-120"/>
+              </a:rPr>
+              <a:t>Article</a:t>
+            </a:r>
+            <a:endParaRPr lang="en-US" sz="950" dirty="0"/>
+          </a:p>
+        </p:txBody>
+      </p:sp>
+      <p:sp>
+        <p:nvSpPr>
+          <p:cNvPr id="18" name="Text 16"/>
+          <p:cNvSpPr/>
+          <p:nvPr/>
+        </p:nvSpPr>
+        <p:spPr>
+          <a:xfrm>
+            <a:off x="804672" y="3813048"/>
+            <a:ext cx="10582351" cy="201168"/>
+          </a:xfrm>
+          <a:prstGeom prst="rect">
+            <a:avLst/>
+          </a:prstGeom>
+          <a:noFill/>
+          <a:ln/>
+        </p:spPr>
+        <p:txBody>
+          <a:bodyPr wrap="square" lIns="0" tIns="0" rIns="0" bIns="0" rtlCol="0" anchor="ctr"/>
+          <a:lstStyle/>
+          <a:p>
+            <a:pPr indent="0" marL="0">
+              <a:buNone/>
+            </a:pPr>
+            <a:r>
+              <a:rPr lang="en-US" sz="1050" dirty="0">
+                <a:solidFill>
+                  <a:srgbClr val="36454F"/>
+                </a:solidFill>
+                <a:latin typeface="Calibri" pitchFamily="34" charset="0"/>
+                <a:ea typeface="Calibri" pitchFamily="34" charset="-122"/>
+                <a:cs typeface="Calibri" pitchFamily="34" charset="-120"/>
+              </a:rPr>
+              <a:t>The transition from lipedema to lipo-lymphedema.</a:t>
+            </a:r>
+            <a:endParaRPr lang="en-US" sz="1050" dirty="0"/>
+          </a:p>
+        </p:txBody>
+      </p:sp>
+      <p:sp>
+        <p:nvSpPr>
+          <p:cNvPr id="19" name="Text 17"/>
+          <p:cNvSpPr/>
+          <p:nvPr/>
+        </p:nvSpPr>
+        <p:spPr>
+          <a:xfrm>
+            <a:off x="804672" y="4014216"/>
+            <a:ext cx="10582351" cy="201168"/>
+          </a:xfrm>
+          <a:prstGeom prst="rect">
+            <a:avLst/>
+          </a:prstGeom>
+          <a:noFill/>
+          <a:ln/>
+        </p:spPr>
+        <p:txBody>
+          <a:bodyPr wrap="square" lIns="0" tIns="0" rIns="0" bIns="0" rtlCol="0" anchor="ctr"/>
+          <a:lstStyle/>
+          <a:p>
+            <a:pPr indent="0" marL="0">
+              <a:buNone/>
+            </a:pPr>
+            <a:r>
+              <a:rPr lang="en-US" sz="850" u="sng" dirty="0">
+                <a:solidFill>
+                  <a:srgbClr val="1C7293"/>
+                </a:solidFill>
+                <a:latin typeface="Calibri" pitchFamily="34" charset="0"/>
+                <a:ea typeface="Calibri" pitchFamily="34" charset="-122"/>
+                <a:cs typeface="Calibri" pitchFamily="34" charset="-120"/>
+                <a:hlinkClick r:id="rId3" invalidUrl="" action="" tgtFrame="" tooltip="" history="1" highlightClick="0" endSnd="0">
+                  <a:extLst>
+                    <a:ext uri="{A12FA001-AC4F-418D-AE19-62706E023703}">
+                      <ahyp:hlinkClr xmlns:ahyp="http://schemas.microsoft.com/office/drawing/2018/hyperlinkcolor" val="tx"/>
+                    </a:ext>
+                  </a:extLst>
+                </a:hlinkClick>
+              </a:rPr>
+              <a:t>https://www.totallipedemacare.com/understanding-stage-4-lipedema-lipo-lymphedema/</a:t>
+            </a:r>
+            <a:endParaRPr lang="en-US" sz="850" dirty="0"/>
+          </a:p>
+        </p:txBody>
+      </p:sp>
+      <p:sp>
+        <p:nvSpPr>
+          <p:cNvPr id="20" name="Shape 18"/>
+          <p:cNvSpPr/>
+          <p:nvPr/>
+        </p:nvSpPr>
+        <p:spPr>
+          <a:xfrm>
+            <a:off x="566928" y="4379976"/>
+            <a:ext cx="11057839" cy="786384"/>
+          </a:xfrm>
+          <a:prstGeom prst="roundRect">
+            <a:avLst>
+              <a:gd name="adj" fmla="val 10465"/>
+            </a:avLst>
+          </a:prstGeom>
+          <a:solidFill>
+            <a:srgbClr val="FFFFFF"/>
+          </a:solidFill>
+          <a:ln w="12700">
+            <a:solidFill>
+              <a:srgbClr val="DCE6E8"/>
+            </a:solidFill>
+            <a:prstDash val="solid"/>
+          </a:ln>
+        </p:spPr>
+      </p:sp>
+      <p:sp>
+        <p:nvSpPr>
+          <p:cNvPr id="21" name="Text 19"/>
+          <p:cNvSpPr/>
+          <p:nvPr/>
+        </p:nvSpPr>
+        <p:spPr>
+          <a:xfrm>
+            <a:off x="804672" y="4471416"/>
+            <a:ext cx="8680399" cy="256032"/>
+          </a:xfrm>
+          <a:prstGeom prst="rect">
+            <a:avLst/>
+          </a:prstGeom>
+          <a:noFill/>
+          <a:ln/>
+        </p:spPr>
+        <p:txBody>
+          <a:bodyPr wrap="square" lIns="0" tIns="0" rIns="0" bIns="0" rtlCol="0" anchor="ctr"/>
+          <a:lstStyle/>
+          <a:p>
+            <a:pPr indent="0" marL="0">
+              <a:buNone/>
+            </a:pPr>
+            <a:r>
+              <a:rPr lang="en-US" sz="1300" b="1" dirty="0">
+                <a:solidFill>
+                  <a:srgbClr val="025462"/>
+                </a:solidFill>
+                <a:latin typeface="Calibri" pitchFamily="34" charset="0"/>
+                <a:ea typeface="Calibri" pitchFamily="34" charset="-122"/>
+                <a:cs typeface="Calibri" pitchFamily="34" charset="-120"/>
+              </a:rPr>
+              <a:t>Differential diagnostics of lipedema and lymphedema</a:t>
+            </a:r>
+            <a:endParaRPr lang="en-US" sz="1300" dirty="0"/>
+          </a:p>
+        </p:txBody>
+      </p:sp>
+      <p:sp>
+        <p:nvSpPr>
+          <p:cNvPr id="22" name="Text 20"/>
+          <p:cNvSpPr/>
+          <p:nvPr/>
+        </p:nvSpPr>
+        <p:spPr>
+          <a:xfrm>
+            <a:off x="9521647" y="4471416"/>
+            <a:ext cx="1828800" cy="256032"/>
+          </a:xfrm>
+          <a:prstGeom prst="rect">
+            <a:avLst/>
+          </a:prstGeom>
+          <a:noFill/>
+          <a:ln/>
+        </p:spPr>
+        <p:txBody>
+          <a:bodyPr wrap="square" lIns="0" tIns="0" rIns="0" bIns="0" rtlCol="0" anchor="ctr"/>
+          <a:lstStyle/>
+          <a:p>
+            <a:pPr algn="r" indent="0" marL="0">
+              <a:buNone/>
+            </a:pPr>
+            <a:r>
+              <a:rPr lang="en-US" sz="950" b="1" dirty="0">
+                <a:solidFill>
+                  <a:srgbClr val="028090"/>
+                </a:solidFill>
+                <a:latin typeface="Calibri" pitchFamily="34" charset="0"/>
+                <a:ea typeface="Calibri" pitchFamily="34" charset="-122"/>
+                <a:cs typeface="Calibri" pitchFamily="34" charset="-120"/>
+              </a:rPr>
+              <a:t>PubMed</a:t>
+            </a:r>
+            <a:endParaRPr lang="en-US" sz="950" dirty="0"/>
+          </a:p>
+        </p:txBody>
+      </p:sp>
+      <p:sp>
+        <p:nvSpPr>
+          <p:cNvPr id="23" name="Text 21"/>
+          <p:cNvSpPr/>
+          <p:nvPr/>
+        </p:nvSpPr>
+        <p:spPr>
+          <a:xfrm>
+            <a:off x="804672" y="4709160"/>
+            <a:ext cx="10582351" cy="201168"/>
+          </a:xfrm>
+          <a:prstGeom prst="rect">
+            <a:avLst/>
+          </a:prstGeom>
+          <a:noFill/>
+          <a:ln/>
+        </p:spPr>
+        <p:txBody>
+          <a:bodyPr wrap="square" lIns="0" tIns="0" rIns="0" bIns="0" rtlCol="0" anchor="ctr"/>
+          <a:lstStyle/>
+          <a:p>
+            <a:pPr indent="0" marL="0">
+              <a:buNone/>
+            </a:pPr>
+            <a:r>
+              <a:rPr lang="en-US" sz="1050" dirty="0">
+                <a:solidFill>
+                  <a:srgbClr val="36454F"/>
+                </a:solidFill>
+                <a:latin typeface="Calibri" pitchFamily="34" charset="0"/>
+                <a:ea typeface="Calibri" pitchFamily="34" charset="-122"/>
+                <a:cs typeface="Calibri" pitchFamily="34" charset="-120"/>
+              </a:rPr>
+              <a:t>Practical guideline. Basis for the differential table.</a:t>
+            </a:r>
+            <a:endParaRPr lang="en-US" sz="1050" dirty="0"/>
+          </a:p>
+        </p:txBody>
+      </p:sp>
+      <p:sp>
+        <p:nvSpPr>
+          <p:cNvPr id="24" name="Text 22"/>
+          <p:cNvSpPr/>
+          <p:nvPr/>
+        </p:nvSpPr>
+        <p:spPr>
+          <a:xfrm>
+            <a:off x="804672" y="4910328"/>
+            <a:ext cx="10582351" cy="201168"/>
+          </a:xfrm>
+          <a:prstGeom prst="rect">
+            <a:avLst/>
+          </a:prstGeom>
+          <a:noFill/>
+          <a:ln/>
+        </p:spPr>
+        <p:txBody>
+          <a:bodyPr wrap="square" lIns="0" tIns="0" rIns="0" bIns="0" rtlCol="0" anchor="ctr"/>
+          <a:lstStyle/>
+          <a:p>
+            <a:pPr indent="0" marL="0">
+              <a:buNone/>
+            </a:pPr>
+            <a:r>
+              <a:rPr lang="en-US" sz="850" u="sng" dirty="0">
+                <a:solidFill>
+                  <a:srgbClr val="1C7293"/>
+                </a:solidFill>
+                <a:latin typeface="Calibri" pitchFamily="34" charset="0"/>
+                <a:ea typeface="Calibri" pitchFamily="34" charset="-122"/>
+                <a:cs typeface="Calibri" pitchFamily="34" charset="-120"/>
+                <a:hlinkClick r:id="rId4" invalidUrl="" action="" tgtFrame="" tooltip="" history="1" highlightClick="0" endSnd="0">
+                  <a:extLst>
+                    <a:ext uri="{A12FA001-AC4F-418D-AE19-62706E023703}">
+                      <ahyp:hlinkClr xmlns:ahyp="http://schemas.microsoft.com/office/drawing/2018/hyperlinkcolor" val="tx"/>
+                    </a:ext>
+                  </a:extLst>
+                </a:hlinkClick>
+              </a:rPr>
+              <a:t>https://pubmed.ncbi.nlm.nih.gov/30280233/</a:t>
+            </a:r>
+            <a:endParaRPr lang="en-US" sz="850" dirty="0"/>
+          </a:p>
+        </p:txBody>
+      </p:sp>
+      <p:sp>
+        <p:nvSpPr>
+          <p:cNvPr id="25" name="Shape 23"/>
+          <p:cNvSpPr/>
+          <p:nvPr/>
+        </p:nvSpPr>
+        <p:spPr>
+          <a:xfrm>
+            <a:off x="566928" y="5276088"/>
+            <a:ext cx="11057839" cy="786384"/>
+          </a:xfrm>
+          <a:prstGeom prst="roundRect">
+            <a:avLst>
+              <a:gd name="adj" fmla="val 10465"/>
+            </a:avLst>
+          </a:prstGeom>
+          <a:solidFill>
+            <a:srgbClr val="FFFFFF"/>
+          </a:solidFill>
+          <a:ln w="12700">
+            <a:solidFill>
+              <a:srgbClr val="DCE6E8"/>
+            </a:solidFill>
+            <a:prstDash val="solid"/>
+          </a:ln>
+        </p:spPr>
+      </p:sp>
+      <p:sp>
+        <p:nvSpPr>
+          <p:cNvPr id="26" name="Text 24"/>
+          <p:cNvSpPr/>
+          <p:nvPr/>
+        </p:nvSpPr>
+        <p:spPr>
+          <a:xfrm>
+            <a:off x="804672" y="5367528"/>
+            <a:ext cx="8680399" cy="256032"/>
+          </a:xfrm>
+          <a:prstGeom prst="rect">
+            <a:avLst/>
+          </a:prstGeom>
+          <a:noFill/>
+          <a:ln/>
+        </p:spPr>
+        <p:txBody>
+          <a:bodyPr wrap="square" lIns="0" tIns="0" rIns="0" bIns="0" rtlCol="0" anchor="ctr"/>
+          <a:lstStyle/>
+          <a:p>
+            <a:pPr indent="0" marL="0">
+              <a:buNone/>
+            </a:pPr>
+            <a:r>
+              <a:rPr lang="en-US" sz="1300" b="1" dirty="0">
+                <a:solidFill>
+                  <a:srgbClr val="025462"/>
+                </a:solidFill>
+                <a:latin typeface="Calibri" pitchFamily="34" charset="0"/>
+                <a:ea typeface="Calibri" pitchFamily="34" charset="-122"/>
+                <a:cs typeface="Calibri" pitchFamily="34" charset="-120"/>
+              </a:rPr>
+              <a:t>Lipedema vs lymphedema — Northwell Health</a:t>
+            </a:r>
+            <a:endParaRPr lang="en-US" sz="1300" dirty="0"/>
+          </a:p>
+        </p:txBody>
+      </p:sp>
+      <p:sp>
+        <p:nvSpPr>
+          <p:cNvPr id="27" name="Text 25"/>
+          <p:cNvSpPr/>
+          <p:nvPr/>
+        </p:nvSpPr>
+        <p:spPr>
+          <a:xfrm>
+            <a:off x="9521647" y="5367528"/>
+            <a:ext cx="1828800" cy="256032"/>
+          </a:xfrm>
+          <a:prstGeom prst="rect">
+            <a:avLst/>
+          </a:prstGeom>
+          <a:noFill/>
+          <a:ln/>
+        </p:spPr>
+        <p:txBody>
+          <a:bodyPr wrap="square" lIns="0" tIns="0" rIns="0" bIns="0" rtlCol="0" anchor="ctr"/>
+          <a:lstStyle/>
+          <a:p>
+            <a:pPr algn="r" indent="0" marL="0">
+              <a:buNone/>
+            </a:pPr>
+            <a:r>
+              <a:rPr lang="en-US" sz="950" b="1" dirty="0">
+                <a:solidFill>
+                  <a:srgbClr val="028090"/>
+                </a:solidFill>
+                <a:latin typeface="Calibri" pitchFamily="34" charset="0"/>
+                <a:ea typeface="Calibri" pitchFamily="34" charset="-122"/>
+                <a:cs typeface="Calibri" pitchFamily="34" charset="-120"/>
+              </a:rPr>
+              <a:t>Article</a:t>
+            </a:r>
+            <a:endParaRPr lang="en-US" sz="950" dirty="0"/>
+          </a:p>
+        </p:txBody>
+      </p:sp>
+      <p:sp>
+        <p:nvSpPr>
+          <p:cNvPr id="28" name="Text 26"/>
+          <p:cNvSpPr/>
+          <p:nvPr/>
+        </p:nvSpPr>
+        <p:spPr>
+          <a:xfrm>
+            <a:off x="804672" y="5605272"/>
+            <a:ext cx="10582351" cy="201168"/>
+          </a:xfrm>
+          <a:prstGeom prst="rect">
+            <a:avLst/>
+          </a:prstGeom>
+          <a:noFill/>
+          <a:ln/>
+        </p:spPr>
+        <p:txBody>
+          <a:bodyPr wrap="square" lIns="0" tIns="0" rIns="0" bIns="0" rtlCol="0" anchor="ctr"/>
+          <a:lstStyle/>
+          <a:p>
+            <a:pPr indent="0" marL="0">
+              <a:buNone/>
+            </a:pPr>
+            <a:r>
+              <a:rPr lang="en-US" sz="1050" dirty="0">
+                <a:solidFill>
+                  <a:srgbClr val="36454F"/>
+                </a:solidFill>
+                <a:latin typeface="Calibri" pitchFamily="34" charset="0"/>
+                <a:ea typeface="Calibri" pitchFamily="34" charset="-122"/>
+                <a:cs typeface="Calibri" pitchFamily="34" charset="-120"/>
+              </a:rPr>
+              <a:t>Plain-language framing useful for patient education.</a:t>
+            </a:r>
+            <a:endParaRPr lang="en-US" sz="1050" dirty="0"/>
+          </a:p>
+        </p:txBody>
+      </p:sp>
+      <p:sp>
+        <p:nvSpPr>
+          <p:cNvPr id="29" name="Text 27"/>
+          <p:cNvSpPr/>
+          <p:nvPr/>
+        </p:nvSpPr>
+        <p:spPr>
+          <a:xfrm>
+            <a:off x="804672" y="5806440"/>
+            <a:ext cx="10582351" cy="201168"/>
+          </a:xfrm>
+          <a:prstGeom prst="rect">
+            <a:avLst/>
+          </a:prstGeom>
+          <a:noFill/>
+          <a:ln/>
+        </p:spPr>
+        <p:txBody>
+          <a:bodyPr wrap="square" lIns="0" tIns="0" rIns="0" bIns="0" rtlCol="0" anchor="ctr"/>
+          <a:lstStyle/>
+          <a:p>
+            <a:pPr indent="0" marL="0">
+              <a:buNone/>
+            </a:pPr>
+            <a:r>
+              <a:rPr lang="en-US" sz="850" u="sng" dirty="0">
+                <a:solidFill>
+                  <a:srgbClr val="1C7293"/>
+                </a:solidFill>
+                <a:latin typeface="Calibri" pitchFamily="34" charset="0"/>
+                <a:ea typeface="Calibri" pitchFamily="34" charset="-122"/>
+                <a:cs typeface="Calibri" pitchFamily="34" charset="-120"/>
+                <a:hlinkClick r:id="rId5" invalidUrl="" action="" tgtFrame="" tooltip="" history="1" highlightClick="0" endSnd="0">
+                  <a:extLst>
+                    <a:ext uri="{A12FA001-AC4F-418D-AE19-62706E023703}">
+                      <ahyp:hlinkClr xmlns:ahyp="http://schemas.microsoft.com/office/drawing/2018/hyperlinkcolor" val="tx"/>
+                    </a:ext>
+                  </a:extLst>
+                </a:hlinkClick>
+              </a:rPr>
+              <a:t>https://www.northwell.edu/news/insights/lipedema-vs-lymphedema-what-to-know</a:t>
+            </a:r>
+            <a:endParaRPr lang="en-US" sz="850" dirty="0"/>
+          </a:p>
+        </p:txBody>
+      </p:sp>
+    </p:spTree>
+  </p:cSld>
+  <p:clrMapOvr>
+    <a:masterClrMapping/>
+  </p:clrMapOvr>
+</p:sld>
+</file>
+
+<file path=ppt/slides/slide33.xml><?xml version="1.0" encoding="utf-8"?>
+<p:sld xmlns:a="http://schemas.openxmlformats.org/drawingml/2006/main" xmlns:r="http://schemas.openxmlformats.org/officeDocument/2006/relationships" xmlns:p="http://schemas.openxmlformats.org/presentationml/2006/main">
+  <p:cSld name="Slide 33">
+    <p:bg>
+      <p:bgPr>
+        <a:solidFill>
+          <a:srgbClr val="F4F8F9"/>
+        </a:solidFill>
+      </p:bgPr>
+    </p:bg>
+    <p:spTree>
+      <p:nvGrpSpPr>
+        <p:cNvPr id="1" name=""/>
+        <p:cNvGrpSpPr/>
+        <p:nvPr/>
+      </p:nvGrpSpPr>
+      <p:grpSpPr>
+        <a:xfrm>
+          <a:off x="0" y="0"/>
+          <a:ext cx="0" cy="0"/>
+          <a:chOff x="0" y="0"/>
+          <a:chExt cx="0" cy="0"/>
+        </a:xfrm>
+      </p:grpSpPr>
+      <p:sp>
+        <p:nvSpPr>
+          <p:cNvPr id="2" name="Text 0"/>
+          <p:cNvSpPr/>
+          <p:nvPr/>
+        </p:nvSpPr>
+        <p:spPr>
+          <a:xfrm>
+            <a:off x="11414455" y="6382512"/>
+            <a:ext cx="457200" cy="274320"/>
+          </a:xfrm>
+          <a:prstGeom prst="rect">
+            <a:avLst/>
+          </a:prstGeom>
+          <a:noFill/>
+          <a:ln/>
+        </p:spPr>
+        <p:txBody>
+          <a:bodyPr wrap="square" lIns="0" tIns="0" rIns="0" bIns="0" rtlCol="0" anchor="ctr"/>
+          <a:lstStyle/>
+          <a:p>
+            <a:pPr algn="r" indent="0" marL="0">
+              <a:buNone/>
+            </a:pPr>
+            <a:r>
+              <a:rPr lang="en-US" sz="1000" dirty="0">
+                <a:solidFill>
+                  <a:srgbClr val="9BB0B8"/>
+                </a:solidFill>
+                <a:latin typeface="Calibri" pitchFamily="34" charset="0"/>
+                <a:ea typeface="Calibri" pitchFamily="34" charset="-122"/>
+                <a:cs typeface="Calibri" pitchFamily="34" charset="-120"/>
+              </a:rPr>
+              <a:t>33</a:t>
+            </a:r>
+            <a:endParaRPr lang="en-US" sz="1000" dirty="0"/>
+          </a:p>
+        </p:txBody>
+      </p:sp>
+      <p:sp>
+        <p:nvSpPr>
+          <p:cNvPr id="3" name="Text 1"/>
+          <p:cNvSpPr/>
+          <p:nvPr/>
+        </p:nvSpPr>
+        <p:spPr>
+          <a:xfrm>
+            <a:off x="566928" y="310896"/>
+            <a:ext cx="11057839" cy="274320"/>
+          </a:xfrm>
+          <a:prstGeom prst="rect">
+            <a:avLst/>
+          </a:prstGeom>
+          <a:noFill/>
+          <a:ln/>
+        </p:spPr>
+        <p:txBody>
+          <a:bodyPr wrap="square" lIns="0" tIns="0" rIns="0" bIns="0" rtlCol="0" anchor="ctr"/>
+          <a:lstStyle/>
+          <a:p>
+            <a:pPr indent="0" marL="0">
+              <a:buNone/>
+            </a:pPr>
+            <a:r>
+              <a:rPr lang="en-US" sz="1100" b="1" spc="200" kern="0" dirty="0">
+                <a:solidFill>
+                  <a:srgbClr val="028090"/>
+                </a:solidFill>
+                <a:latin typeface="Calibri" pitchFamily="34" charset="0"/>
+                <a:ea typeface="Calibri" pitchFamily="34" charset="-122"/>
+                <a:cs typeface="Calibri" pitchFamily="34" charset="-120"/>
+              </a:rPr>
+              <a:t>CLOSE</a:t>
+            </a:r>
+            <a:endParaRPr lang="en-US" sz="1100" dirty="0"/>
+          </a:p>
+        </p:txBody>
+      </p:sp>
+      <p:sp>
+        <p:nvSpPr>
+          <p:cNvPr id="4" name="Text 2"/>
+          <p:cNvSpPr/>
+          <p:nvPr/>
+        </p:nvSpPr>
+        <p:spPr>
+          <a:xfrm>
+            <a:off x="566928" y="603504"/>
+            <a:ext cx="11057839" cy="777240"/>
+          </a:xfrm>
+          <a:prstGeom prst="rect">
+            <a:avLst/>
+          </a:prstGeom>
+          <a:noFill/>
+          <a:ln/>
+        </p:spPr>
+        <p:txBody>
+          <a:bodyPr wrap="square" lIns="0" tIns="0" rIns="0" bIns="0" rtlCol="0" anchor="t"/>
+          <a:lstStyle/>
+          <a:p>
+            <a:pPr indent="0" marL="0">
+              <a:buNone/>
+            </a:pPr>
+            <a:r>
+              <a:rPr lang="en-US" sz="3400" b="1" dirty="0">
+                <a:solidFill>
+                  <a:srgbClr val="025462"/>
+                </a:solidFill>
+                <a:latin typeface="Cambria" pitchFamily="34" charset="0"/>
+                <a:ea typeface="Cambria" pitchFamily="34" charset="-122"/>
+                <a:cs typeface="Cambria" pitchFamily="34" charset="-120"/>
+              </a:rPr>
+              <a:t>Key Takeaways</a:t>
+            </a:r>
+            <a:endParaRPr lang="en-US" sz="3400" dirty="0"/>
+          </a:p>
+        </p:txBody>
+      </p:sp>
+      <p:sp>
+        <p:nvSpPr>
+          <p:cNvPr id="5" name="Text 3"/>
+          <p:cNvSpPr/>
+          <p:nvPr/>
+        </p:nvSpPr>
+        <p:spPr>
+          <a:xfrm>
+            <a:off x="566928" y="1554480"/>
+            <a:ext cx="5391760" cy="4572000"/>
+          </a:xfrm>
+          <a:prstGeom prst="rect">
+            <a:avLst/>
+          </a:prstGeom>
+          <a:noFill/>
+          <a:ln/>
+        </p:spPr>
+        <p:txBody>
+          <a:bodyPr wrap="square" lIns="0" tIns="0" rIns="0" bIns="0" rtlCol="0" anchor="t"/>
+          <a:lstStyle/>
+          <a:p>
+            <a:pPr indent="0" marL="0">
+              <a:buNone/>
+            </a:pPr>
+            <a:r>
+              <a:rPr lang="en-US" sz="1300" b="1" dirty="0">
+                <a:solidFill>
+                  <a:srgbClr val="028090"/>
+                </a:solidFill>
+                <a:latin typeface="Calibri" pitchFamily="34" charset="0"/>
+                <a:ea typeface="Calibri" pitchFamily="34" charset="-122"/>
+                <a:cs typeface="Calibri" pitchFamily="34" charset="-120"/>
+              </a:rPr>
+              <a:t>1.  </a:t>
+            </a:r>
+            <a:pPr indent="0" marL="0">
+              <a:spcAft>
+                <a:spcPts val="900"/>
+              </a:spcAft>
+              <a:buNone/>
+            </a:pPr>
+            <a:r>
+              <a:rPr lang="en-US" sz="1300" dirty="0">
+                <a:solidFill>
+                  <a:srgbClr val="1B2A30"/>
+                </a:solidFill>
+                <a:latin typeface="Calibri" pitchFamily="34" charset="0"/>
+                <a:ea typeface="Calibri" pitchFamily="34" charset="-122"/>
+                <a:cs typeface="Calibri" pitchFamily="34" charset="-120"/>
+              </a:rPr>
+              <a:t>Lymphedema is mechanical insufficiency — high-protein, progressive, and self-reinforcing if untreated.</a:t>
+            </a:r>
+            <a:endParaRPr lang="en-US" sz="1300" dirty="0"/>
+          </a:p>
+          <a:p>
+            <a:pPr indent="0" marL="0">
+              <a:buNone/>
+            </a:pPr>
+            <a:r>
+              <a:rPr lang="en-US" sz="1300" b="1" dirty="0">
+                <a:solidFill>
+                  <a:srgbClr val="028090"/>
+                </a:solidFill>
+                <a:latin typeface="Calibri" pitchFamily="34" charset="0"/>
+                <a:ea typeface="Calibri" pitchFamily="34" charset="-122"/>
+                <a:cs typeface="Calibri" pitchFamily="34" charset="-120"/>
+              </a:rPr>
+              <a:t>2.  </a:t>
+            </a:r>
+            <a:pPr indent="0" marL="0">
+              <a:spcAft>
+                <a:spcPts val="900"/>
+              </a:spcAft>
+              <a:buNone/>
+            </a:pPr>
+            <a:r>
+              <a:rPr lang="en-US" sz="1300" dirty="0">
+                <a:solidFill>
+                  <a:srgbClr val="1B2A30"/>
+                </a:solidFill>
+                <a:latin typeface="Calibri" pitchFamily="34" charset="0"/>
+                <a:ea typeface="Calibri" pitchFamily="34" charset="-122"/>
+                <a:cs typeface="Calibri" pitchFamily="34" charset="-120"/>
+              </a:rPr>
+              <a:t>Symptoms precede visible swelling. Stage 0 is real and is the best time to intervene.</a:t>
+            </a:r>
+            <a:endParaRPr lang="en-US" sz="1300" dirty="0"/>
+          </a:p>
+          <a:p>
+            <a:pPr indent="0" marL="0">
+              <a:buNone/>
+            </a:pPr>
+            <a:r>
+              <a:rPr lang="en-US" sz="1300" b="1" dirty="0">
+                <a:solidFill>
+                  <a:srgbClr val="028090"/>
+                </a:solidFill>
+                <a:latin typeface="Calibri" pitchFamily="34" charset="0"/>
+                <a:ea typeface="Calibri" pitchFamily="34" charset="-122"/>
+                <a:cs typeface="Calibri" pitchFamily="34" charset="-120"/>
+              </a:rPr>
+              <a:t>3.  </a:t>
+            </a:r>
+            <a:pPr indent="0" marL="0">
+              <a:spcAft>
+                <a:spcPts val="900"/>
+              </a:spcAft>
+              <a:buNone/>
+            </a:pPr>
+            <a:r>
+              <a:rPr lang="en-US" sz="1300" dirty="0">
+                <a:solidFill>
+                  <a:srgbClr val="1B2A30"/>
+                </a:solidFill>
+                <a:latin typeface="Calibri" pitchFamily="34" charset="0"/>
+                <a:ea typeface="Calibri" pitchFamily="34" charset="-122"/>
+                <a:cs typeface="Calibri" pitchFamily="34" charset="-120"/>
+              </a:rPr>
+              <a:t>Stemmer's sign is fast, free, and diagnostic when positive.</a:t>
+            </a:r>
+            <a:endParaRPr lang="en-US" sz="1300" dirty="0"/>
+          </a:p>
+          <a:p>
+            <a:pPr indent="0" marL="0">
+              <a:buNone/>
+            </a:pPr>
+            <a:r>
+              <a:rPr lang="en-US" sz="1300" b="1" dirty="0">
+                <a:solidFill>
+                  <a:srgbClr val="028090"/>
+                </a:solidFill>
+                <a:latin typeface="Calibri" pitchFamily="34" charset="0"/>
+                <a:ea typeface="Calibri" pitchFamily="34" charset="-122"/>
+                <a:cs typeface="Calibri" pitchFamily="34" charset="-120"/>
+              </a:rPr>
+              <a:t>4.  </a:t>
+            </a:r>
+            <a:pPr indent="0" marL="0">
+              <a:spcAft>
+                <a:spcPts val="900"/>
+              </a:spcAft>
+              <a:buNone/>
+            </a:pPr>
+            <a:r>
+              <a:rPr lang="en-US" sz="1300" dirty="0">
+                <a:solidFill>
+                  <a:srgbClr val="1B2A30"/>
+                </a:solidFill>
+                <a:latin typeface="Calibri" pitchFamily="34" charset="0"/>
+                <a:ea typeface="Calibri" pitchFamily="34" charset="-122"/>
+                <a:cs typeface="Calibri" pitchFamily="34" charset="-120"/>
+              </a:rPr>
+              <a:t>Four ISL stages: 0 latent, I reversible, II irreversible/fibrotic, III elephantiasis.</a:t>
+            </a:r>
+            <a:endParaRPr lang="en-US" sz="1300" dirty="0"/>
+          </a:p>
+          <a:p>
+            <a:pPr indent="0" marL="0">
+              <a:buNone/>
+            </a:pPr>
+            <a:r>
+              <a:rPr lang="en-US" sz="1300" b="1" dirty="0">
+                <a:solidFill>
+                  <a:srgbClr val="028090"/>
+                </a:solidFill>
+                <a:latin typeface="Calibri" pitchFamily="34" charset="0"/>
+                <a:ea typeface="Calibri" pitchFamily="34" charset="-122"/>
+                <a:cs typeface="Calibri" pitchFamily="34" charset="-120"/>
+              </a:rPr>
+              <a:t>5.  </a:t>
+            </a:r>
+            <a:pPr indent="0" marL="0">
+              <a:spcAft>
+                <a:spcPts val="900"/>
+              </a:spcAft>
+              <a:buNone/>
+            </a:pPr>
+            <a:r>
+              <a:rPr lang="en-US" sz="1300" dirty="0">
+                <a:solidFill>
+                  <a:srgbClr val="1B2A30"/>
+                </a:solidFill>
+                <a:latin typeface="Calibri" pitchFamily="34" charset="0"/>
+                <a:ea typeface="Calibri" pitchFamily="34" charset="-122"/>
+                <a:cs typeface="Calibri" pitchFamily="34" charset="-120"/>
+              </a:rPr>
+              <a:t>CDT has four components. Compression is the one that holds the result.</a:t>
+            </a:r>
+            <a:endParaRPr lang="en-US" sz="1300" dirty="0"/>
+          </a:p>
+        </p:txBody>
+      </p:sp>
+      <p:sp>
+        <p:nvSpPr>
+          <p:cNvPr id="6" name="Text 4"/>
+          <p:cNvSpPr/>
+          <p:nvPr/>
+        </p:nvSpPr>
+        <p:spPr>
+          <a:xfrm>
+            <a:off x="6233008" y="1554480"/>
+            <a:ext cx="5391760" cy="4572000"/>
+          </a:xfrm>
+          <a:prstGeom prst="rect">
+            <a:avLst/>
+          </a:prstGeom>
+          <a:noFill/>
+          <a:ln/>
+        </p:spPr>
+        <p:txBody>
+          <a:bodyPr wrap="square" lIns="0" tIns="0" rIns="0" bIns="0" rtlCol="0" anchor="t"/>
+          <a:lstStyle/>
+          <a:p>
+            <a:pPr indent="0" marL="0">
+              <a:buNone/>
+            </a:pPr>
+            <a:r>
+              <a:rPr lang="en-US" sz="1300" b="1" dirty="0">
+                <a:solidFill>
+                  <a:srgbClr val="028090"/>
+                </a:solidFill>
+                <a:latin typeface="Calibri" pitchFamily="34" charset="0"/>
+                <a:ea typeface="Calibri" pitchFamily="34" charset="-122"/>
+                <a:cs typeface="Calibri" pitchFamily="34" charset="-120"/>
+              </a:rPr>
+              <a:t>6.  </a:t>
+            </a:r>
+            <a:pPr indent="0" marL="0">
+              <a:spcAft>
+                <a:spcPts val="900"/>
+              </a:spcAft>
+              <a:buNone/>
+            </a:pPr>
+            <a:r>
+              <a:rPr lang="en-US" sz="1300" dirty="0">
+                <a:solidFill>
+                  <a:srgbClr val="1B2A30"/>
+                </a:solidFill>
+                <a:latin typeface="Calibri" pitchFamily="34" charset="0"/>
+                <a:ea typeface="Calibri" pitchFamily="34" charset="-122"/>
+                <a:cs typeface="Calibri" pitchFamily="34" charset="-120"/>
+              </a:rPr>
+              <a:t>Exercise under compression is treatment. Resistance training is safe.</a:t>
+            </a:r>
+            <a:endParaRPr lang="en-US" sz="1300" dirty="0"/>
+          </a:p>
+          <a:p>
+            <a:pPr indent="0" marL="0">
+              <a:buNone/>
+            </a:pPr>
+            <a:r>
+              <a:rPr lang="en-US" sz="1300" b="1" dirty="0">
+                <a:solidFill>
+                  <a:srgbClr val="028090"/>
+                </a:solidFill>
+                <a:latin typeface="Calibri" pitchFamily="34" charset="0"/>
+                <a:ea typeface="Calibri" pitchFamily="34" charset="-122"/>
+                <a:cs typeface="Calibri" pitchFamily="34" charset="-120"/>
+              </a:rPr>
+              <a:t>7.  </a:t>
+            </a:r>
+            <a:pPr indent="0" marL="0">
+              <a:spcAft>
+                <a:spcPts val="900"/>
+              </a:spcAft>
+              <a:buNone/>
+            </a:pPr>
+            <a:r>
+              <a:rPr lang="en-US" sz="1300" dirty="0">
+                <a:solidFill>
+                  <a:srgbClr val="1B2A30"/>
+                </a:solidFill>
+                <a:latin typeface="Calibri" pitchFamily="34" charset="0"/>
+                <a:ea typeface="Calibri" pitchFamily="34" charset="-122"/>
+                <a:cs typeface="Calibri" pitchFamily="34" charset="-120"/>
+              </a:rPr>
+              <a:t>Lipedema is painful, symmetrical, spares the feet, and has a negative Stemmer.</a:t>
+            </a:r>
+            <a:endParaRPr lang="en-US" sz="1300" dirty="0"/>
+          </a:p>
+          <a:p>
+            <a:pPr indent="0" marL="0">
+              <a:buNone/>
+            </a:pPr>
+            <a:r>
+              <a:rPr lang="en-US" sz="1300" b="1" dirty="0">
+                <a:solidFill>
+                  <a:srgbClr val="028090"/>
+                </a:solidFill>
+                <a:latin typeface="Calibri" pitchFamily="34" charset="0"/>
+                <a:ea typeface="Calibri" pitchFamily="34" charset="-122"/>
+                <a:cs typeface="Calibri" pitchFamily="34" charset="-120"/>
+              </a:rPr>
+              <a:t>8.  </a:t>
+            </a:r>
+            <a:pPr indent="0" marL="0">
+              <a:spcAft>
+                <a:spcPts val="900"/>
+              </a:spcAft>
+              <a:buNone/>
+            </a:pPr>
+            <a:r>
+              <a:rPr lang="en-US" sz="1300" dirty="0">
+                <a:solidFill>
+                  <a:srgbClr val="1B2A30"/>
+                </a:solidFill>
+                <a:latin typeface="Calibri" pitchFamily="34" charset="0"/>
+                <a:ea typeface="Calibri" pitchFamily="34" charset="-122"/>
+                <a:cs typeface="Calibri" pitchFamily="34" charset="-120"/>
+              </a:rPr>
+              <a:t>Lipedema is staged 1–3, with lipo-lymphedema as a contested Stage 4.</a:t>
+            </a:r>
+            <a:endParaRPr lang="en-US" sz="1300" dirty="0"/>
+          </a:p>
+          <a:p>
+            <a:pPr indent="0" marL="0">
+              <a:buNone/>
+            </a:pPr>
+            <a:r>
+              <a:rPr lang="en-US" sz="1300" b="1" dirty="0">
+                <a:solidFill>
+                  <a:srgbClr val="028090"/>
+                </a:solidFill>
+                <a:latin typeface="Calibri" pitchFamily="34" charset="0"/>
+                <a:ea typeface="Calibri" pitchFamily="34" charset="-122"/>
+                <a:cs typeface="Calibri" pitchFamily="34" charset="-120"/>
+              </a:rPr>
+              <a:t>9.  </a:t>
+            </a:r>
+            <a:pPr indent="0" marL="0">
+              <a:spcAft>
+                <a:spcPts val="900"/>
+              </a:spcAft>
+              <a:buNone/>
+            </a:pPr>
+            <a:r>
+              <a:rPr lang="en-US" sz="1300" dirty="0">
+                <a:solidFill>
+                  <a:srgbClr val="1B2A30"/>
+                </a:solidFill>
+                <a:latin typeface="Calibri" pitchFamily="34" charset="0"/>
+                <a:ea typeface="Calibri" pitchFamily="34" charset="-122"/>
+                <a:cs typeface="Calibri" pitchFamily="34" charset="-120"/>
+              </a:rPr>
+              <a:t>Every episode of cellulitis makes the underlying disease worse.</a:t>
+            </a:r>
+            <a:endParaRPr lang="en-US" sz="1300" dirty="0"/>
+          </a:p>
+          <a:p>
+            <a:pPr indent="0" marL="0">
+              <a:buNone/>
+            </a:pPr>
+            <a:r>
+              <a:rPr lang="en-US" sz="1300" b="1" dirty="0">
+                <a:solidFill>
+                  <a:srgbClr val="028090"/>
+                </a:solidFill>
+                <a:latin typeface="Calibri" pitchFamily="34" charset="0"/>
+                <a:ea typeface="Calibri" pitchFamily="34" charset="-122"/>
+                <a:cs typeface="Calibri" pitchFamily="34" charset="-120"/>
+              </a:rPr>
+              <a:t>10.  </a:t>
+            </a:r>
+            <a:pPr indent="0" marL="0">
+              <a:spcAft>
+                <a:spcPts val="900"/>
+              </a:spcAft>
+              <a:buNone/>
+            </a:pPr>
+            <a:r>
+              <a:rPr lang="en-US" sz="1300" dirty="0">
+                <a:solidFill>
+                  <a:srgbClr val="1B2A30"/>
+                </a:solidFill>
+                <a:latin typeface="Calibri" pitchFamily="34" charset="0"/>
+                <a:ea typeface="Calibri" pitchFamily="34" charset="-122"/>
+                <a:cs typeface="Calibri" pitchFamily="34" charset="-120"/>
+              </a:rPr>
+              <a:t>Patient education and Phase II adherence determine long-term outcome.</a:t>
+            </a:r>
+            <a:endParaRPr lang="en-US" sz="1300" dirty="0"/>
+          </a:p>
+        </p:txBody>
+      </p:sp>
+    </p:spTree>
+  </p:cSld>
+  <p:clrMapOvr>
+    <a:masterClrMapping/>
+  </p:clrMapOvr>
+</p:sld>
+</file>
+
+<file path=ppt/slides/slide34.xml><?xml version="1.0" encoding="utf-8"?>
+<p:sld xmlns:a="http://schemas.openxmlformats.org/drawingml/2006/main" xmlns:r="http://schemas.openxmlformats.org/officeDocument/2006/relationships" xmlns:p="http://schemas.openxmlformats.org/presentationml/2006/main">
+  <p:cSld name="Slide 34">
     <p:bg>
       <p:bgPr>
         <a:solidFill>
@@ -22184,11 +24777,11 @@
         <p:spPr>
           <a:xfrm>
             <a:off x="566928" y="2231136"/>
-            <a:ext cx="5428336" cy="1989963"/>
+            <a:ext cx="5428336" cy="4059936"/>
           </a:xfrm>
           <a:prstGeom prst="roundRect">
             <a:avLst>
-              <a:gd name="adj" fmla="val 4136"/>
+              <a:gd name="adj" fmla="val 2027"/>
             </a:avLst>
           </a:prstGeom>
           <a:solidFill>
@@ -22250,7 +24843,7 @@
         <p:spPr>
           <a:xfrm>
             <a:off x="786384" y="2724912"/>
-            <a:ext cx="4989424" cy="1331595"/>
+            <a:ext cx="4989424" cy="3401568"/>
           </a:xfrm>
           <a:prstGeom prst="rect">
             <a:avLst/>
@@ -22386,11 +24979,11 @@
         <p:spPr>
           <a:xfrm>
             <a:off x="6196432" y="2231136"/>
-            <a:ext cx="5428336" cy="2559177"/>
+            <a:ext cx="5428336" cy="4059936"/>
           </a:xfrm>
           <a:prstGeom prst="roundRect">
             <a:avLst>
-              <a:gd name="adj" fmla="val 3216"/>
+              <a:gd name="adj" fmla="val 2027"/>
             </a:avLst>
           </a:prstGeom>
           <a:solidFill>
@@ -22452,7 +25045,7 @@
         <p:spPr>
           <a:xfrm>
             <a:off x="6415888" y="2724912"/>
-            <a:ext cx="4989424" cy="1900809"/>
+            <a:ext cx="4989424" cy="3401568"/>
           </a:xfrm>
           <a:prstGeom prst="rect">
             <a:avLst/>
@@ -23017,11 +25610,11 @@
         <p:spPr>
           <a:xfrm>
             <a:off x="566928" y="2231136"/>
-            <a:ext cx="5428336" cy="2274570"/>
+            <a:ext cx="5428336" cy="4059936"/>
           </a:xfrm>
           <a:prstGeom prst="roundRect">
             <a:avLst>
-              <a:gd name="adj" fmla="val 3618"/>
+              <a:gd name="adj" fmla="val 2027"/>
             </a:avLst>
           </a:prstGeom>
           <a:solidFill>
@@ -23083,7 +25676,7 @@
         <p:spPr>
           <a:xfrm>
             <a:off x="786384" y="2724912"/>
-            <a:ext cx="4989424" cy="1616202"/>
+            <a:ext cx="4989424" cy="3401568"/>
           </a:xfrm>
           <a:prstGeom prst="rect">
             <a:avLst/>
@@ -23240,11 +25833,11 @@
         <p:spPr>
           <a:xfrm>
             <a:off x="6196432" y="2231136"/>
-            <a:ext cx="5428336" cy="2843784"/>
+            <a:ext cx="5428336" cy="4059936"/>
           </a:xfrm>
           <a:prstGeom prst="roundRect">
             <a:avLst>
-              <a:gd name="adj" fmla="val 2894"/>
+              <a:gd name="adj" fmla="val 2027"/>
             </a:avLst>
           </a:prstGeom>
           <a:solidFill>
@@ -23306,7 +25899,7 @@
         <p:spPr>
           <a:xfrm>
             <a:off x="6415888" y="2724912"/>
-            <a:ext cx="4989424" cy="2185416"/>
+            <a:ext cx="4989424" cy="3401568"/>
           </a:xfrm>
           <a:prstGeom prst="rect">
             <a:avLst/>
@@ -23744,11 +26337,11 @@
         <p:spPr>
           <a:xfrm>
             <a:off x="566928" y="2231136"/>
-            <a:ext cx="3551834" cy="2788920"/>
+            <a:ext cx="3551834" cy="4059936"/>
           </a:xfrm>
           <a:prstGeom prst="roundRect">
             <a:avLst>
-              <a:gd name="adj" fmla="val 2951"/>
+              <a:gd name="adj" fmla="val 2317"/>
             </a:avLst>
           </a:prstGeom>
           <a:solidFill>
@@ -23810,7 +26403,7 @@
         <p:spPr>
           <a:xfrm>
             <a:off x="786384" y="2724912"/>
-            <a:ext cx="3112922" cy="2130552"/>
+            <a:ext cx="3112922" cy="3401568"/>
           </a:xfrm>
           <a:prstGeom prst="rect">
             <a:avLst/>
@@ -23937,11 +26530,11 @@
         <p:spPr>
           <a:xfrm>
             <a:off x="4319930" y="2231136"/>
-            <a:ext cx="3551834" cy="2843784"/>
+            <a:ext cx="3551834" cy="4059936"/>
           </a:xfrm>
           <a:prstGeom prst="roundRect">
             <a:avLst>
-              <a:gd name="adj" fmla="val 2894"/>
+              <a:gd name="adj" fmla="val 2317"/>
             </a:avLst>
           </a:prstGeom>
           <a:solidFill>
@@ -24003,7 +26596,7 @@
         <p:spPr>
           <a:xfrm>
             <a:off x="4539386" y="2724912"/>
-            <a:ext cx="3112922" cy="2185416"/>
+            <a:ext cx="3112922" cy="3401568"/>
           </a:xfrm>
           <a:prstGeom prst="rect">
             <a:avLst/>
@@ -24151,11 +26744,11 @@
         <p:spPr>
           <a:xfrm>
             <a:off x="8072933" y="2231136"/>
-            <a:ext cx="3551834" cy="2219706"/>
+            <a:ext cx="3551834" cy="4059936"/>
           </a:xfrm>
           <a:prstGeom prst="roundRect">
             <a:avLst>
-              <a:gd name="adj" fmla="val 3708"/>
+              <a:gd name="adj" fmla="val 2317"/>
             </a:avLst>
           </a:prstGeom>
           <a:solidFill>
@@ -24217,7 +26810,7 @@
         <p:spPr>
           <a:xfrm>
             <a:off x="8292389" y="2724912"/>
-            <a:ext cx="3112922" cy="1561338"/>
+            <a:ext cx="3112922" cy="3401568"/>
           </a:xfrm>
           <a:prstGeom prst="rect">
             <a:avLst/>
@@ -24513,11 +27106,11 @@
         <p:spPr>
           <a:xfrm>
             <a:off x="566928" y="2231136"/>
-            <a:ext cx="5754319" cy="1844421"/>
+            <a:ext cx="5754319" cy="1869059"/>
           </a:xfrm>
           <a:prstGeom prst="roundRect">
             <a:avLst>
-              <a:gd name="adj" fmla="val 4462"/>
+              <a:gd name="adj" fmla="val 4403"/>
             </a:avLst>
           </a:prstGeom>
           <a:solidFill>
@@ -24556,7 +27149,7 @@
               <a:buNone/>
             </a:pPr>
             <a:r>
-              <a:rPr lang="en-US" sz="1200" b="1" dirty="0">
+              <a:rPr lang="en-US" sz="1100" b="1" dirty="0">
                 <a:solidFill>
                   <a:srgbClr val="025462"/>
                 </a:solidFill>
@@ -24566,7 +27159,7 @@
               </a:rPr>
               <a:t>History</a:t>
             </a:r>
-            <a:endParaRPr lang="en-US" sz="1200" dirty="0"/>
+            <a:endParaRPr lang="en-US" sz="1100" dirty="0"/>
           </a:p>
         </p:txBody>
       </p:sp>
@@ -24579,7 +27172,7 @@
         <p:spPr>
           <a:xfrm>
             <a:off x="822960" y="2706624"/>
-            <a:ext cx="5242255" cy="1204341"/>
+            <a:ext cx="5242255" cy="1228979"/>
           </a:xfrm>
           <a:prstGeom prst="rect">
             <a:avLst/>
@@ -24599,7 +27192,7 @@
               <a:buChar char="•"/>
             </a:pPr>
             <a:r>
-              <a:rPr lang="en-US" sz="1050" dirty="0">
+              <a:rPr lang="en-US" sz="950" dirty="0">
                 <a:solidFill>
                   <a:srgbClr val="1B2A30"/>
                 </a:solidFill>
@@ -24609,7 +27202,7 @@
               </a:rPr>
               <a:t>Onset, duration, progression, and whether it resolves overnight</a:t>
             </a:r>
-            <a:endParaRPr lang="en-US" sz="1050" dirty="0"/>
+            <a:endParaRPr lang="en-US" sz="950" dirty="0"/>
           </a:p>
           <a:p>
             <a:pPr marL="190500" indent="-190500">
@@ -24620,7 +27213,7 @@
               <a:buChar char="•"/>
             </a:pPr>
             <a:r>
-              <a:rPr lang="en-US" sz="1050" dirty="0">
+              <a:rPr lang="en-US" sz="950" dirty="0">
                 <a:solidFill>
                   <a:srgbClr val="1B2A30"/>
                 </a:solidFill>
@@ -24630,7 +27223,7 @@
               </a:rPr>
               <a:t>Surgical and oncologic history — nodes removed, radiation fields</a:t>
             </a:r>
-            <a:endParaRPr lang="en-US" sz="1050" dirty="0"/>
+            <a:endParaRPr lang="en-US" sz="950" dirty="0"/>
           </a:p>
           <a:p>
             <a:pPr marL="190500" indent="-190500">
@@ -24641,7 +27234,7 @@
               <a:buChar char="•"/>
             </a:pPr>
             <a:r>
-              <a:rPr lang="en-US" sz="1050" dirty="0">
+              <a:rPr lang="en-US" sz="950" dirty="0">
                 <a:solidFill>
                   <a:srgbClr val="1B2A30"/>
                 </a:solidFill>
@@ -24651,7 +27244,7 @@
               </a:rPr>
               <a:t>Infection history — every episode of cellulitis</a:t>
             </a:r>
-            <a:endParaRPr lang="en-US" sz="1050" dirty="0"/>
+            <a:endParaRPr lang="en-US" sz="950" dirty="0"/>
           </a:p>
           <a:p>
             <a:pPr marL="190500" indent="-190500">
@@ -24662,7 +27255,7 @@
               <a:buChar char="•"/>
             </a:pPr>
             <a:r>
-              <a:rPr lang="en-US" sz="1050" dirty="0">
+              <a:rPr lang="en-US" sz="950" dirty="0">
                 <a:solidFill>
                   <a:srgbClr val="1B2A30"/>
                 </a:solidFill>
@@ -24672,7 +27265,7 @@
               </a:rPr>
               <a:t>Family history (suggests primary lymphedema or lipedema)</a:t>
             </a:r>
-            <a:endParaRPr lang="en-US" sz="1050" dirty="0"/>
+            <a:endParaRPr lang="en-US" sz="950" dirty="0"/>
           </a:p>
           <a:p>
             <a:pPr marL="190500" indent="-190500">
@@ -24683,7 +27276,7 @@
               <a:buChar char="•"/>
             </a:pPr>
             <a:r>
-              <a:rPr lang="en-US" sz="1050" dirty="0">
+              <a:rPr lang="en-US" sz="950" dirty="0">
                 <a:solidFill>
                   <a:srgbClr val="1B2A30"/>
                 </a:solidFill>
@@ -24693,7 +27286,7 @@
               </a:rPr>
               <a:t>Travel history (filariasis), cardiac, renal, and hepatic history</a:t>
             </a:r>
-            <a:endParaRPr lang="en-US" sz="1050" dirty="0"/>
+            <a:endParaRPr lang="en-US" sz="950" dirty="0"/>
           </a:p>
         </p:txBody>
       </p:sp>
@@ -24705,12 +27298,12 @@
         </p:nvSpPr>
         <p:spPr>
           <a:xfrm>
-            <a:off x="566928" y="4240149"/>
-            <a:ext cx="5754319" cy="1968246"/>
+            <a:off x="566928" y="4264787"/>
+            <a:ext cx="5754319" cy="1814195"/>
           </a:xfrm>
           <a:prstGeom prst="roundRect">
             <a:avLst>
-              <a:gd name="adj" fmla="val 4181"/>
+              <a:gd name="adj" fmla="val 4536"/>
             </a:avLst>
           </a:prstGeom>
           <a:solidFill>
@@ -24732,7 +27325,7 @@
         </p:nvSpPr>
         <p:spPr>
           <a:xfrm>
-            <a:off x="822960" y="4368165"/>
+            <a:off x="822960" y="4392803"/>
             <a:ext cx="5242255" cy="274320"/>
           </a:xfrm>
           <a:prstGeom prst="rect">
@@ -24749,7 +27342,7 @@
               <a:buNone/>
             </a:pPr>
             <a:r>
-              <a:rPr lang="en-US" sz="1200" b="1" dirty="0">
+              <a:rPr lang="en-US" sz="1100" b="1" dirty="0">
                 <a:solidFill>
                   <a:srgbClr val="025462"/>
                 </a:solidFill>
@@ -24759,7 +27352,7 @@
               </a:rPr>
               <a:t>Physical examination</a:t>
             </a:r>
-            <a:endParaRPr lang="en-US" sz="1200" dirty="0"/>
+            <a:endParaRPr lang="en-US" sz="1100" dirty="0"/>
           </a:p>
         </p:txBody>
       </p:sp>
@@ -24771,8 +27364,8 @@
         </p:nvSpPr>
         <p:spPr>
           <a:xfrm>
-            <a:off x="822960" y="4715637"/>
-            <a:ext cx="5242255" cy="1328166"/>
+            <a:off x="822960" y="4740275"/>
+            <a:ext cx="5242255" cy="1174115"/>
           </a:xfrm>
           <a:prstGeom prst="rect">
             <a:avLst/>
@@ -24792,7 +27385,7 @@
               <a:buChar char="•"/>
             </a:pPr>
             <a:r>
-              <a:rPr lang="en-US" sz="1050" b="1" dirty="0">
+              <a:rPr lang="en-US" sz="950" b="1" dirty="0">
                 <a:solidFill>
                   <a:srgbClr val="1B2A30"/>
                 </a:solidFill>
@@ -24809,7 +27402,7 @@
               <a:buNone/>
             </a:pPr>
             <a:r>
-              <a:rPr lang="en-US" sz="1050" dirty="0">
+              <a:rPr lang="en-US" sz="950" dirty="0">
                 <a:solidFill>
                   <a:srgbClr val="1B2A30"/>
                 </a:solidFill>
@@ -24819,7 +27412,7 @@
               </a:rPr>
               <a:t> — attempt to pinch and lift the skin fold at the base of the 2nd toe or finger. Cannot lift = positive = lymphedema. Positive is diagnostic; negative does not rule it out.</a:t>
             </a:r>
-            <a:endParaRPr lang="en-US" sz="1050" dirty="0"/>
+            <a:endParaRPr lang="en-US" sz="950" dirty="0"/>
           </a:p>
           <a:p>
             <a:pPr marL="190500" indent="-190500">
@@ -24830,7 +27423,7 @@
               <a:buChar char="•"/>
             </a:pPr>
             <a:r>
-              <a:rPr lang="en-US" sz="1050" b="1" dirty="0">
+              <a:rPr lang="en-US" sz="950" b="1" dirty="0">
                 <a:solidFill>
                   <a:srgbClr val="1B2A30"/>
                 </a:solidFill>
@@ -24847,7 +27440,7 @@
               <a:buNone/>
             </a:pPr>
             <a:r>
-              <a:rPr lang="en-US" sz="1050" dirty="0">
+              <a:rPr lang="en-US" sz="950" dirty="0">
                 <a:solidFill>
                   <a:srgbClr val="1B2A30"/>
                 </a:solidFill>
@@ -24857,7 +27450,7 @@
               </a:rPr>
               <a:t> — depth and rebound time, graded 1+ to 4+</a:t>
             </a:r>
-            <a:endParaRPr lang="en-US" sz="1050" dirty="0"/>
+            <a:endParaRPr lang="en-US" sz="950" dirty="0"/>
           </a:p>
           <a:p>
             <a:pPr marL="190500" indent="-190500">
@@ -24868,7 +27461,7 @@
               <a:buChar char="•"/>
             </a:pPr>
             <a:r>
-              <a:rPr lang="en-US" sz="1050" b="1" dirty="0">
+              <a:rPr lang="en-US" sz="950" b="1" dirty="0">
                 <a:solidFill>
                   <a:srgbClr val="1B2A30"/>
                 </a:solidFill>
@@ -24885,7 +27478,7 @@
               <a:buNone/>
             </a:pPr>
             <a:r>
-              <a:rPr lang="en-US" sz="1050" dirty="0">
+              <a:rPr lang="en-US" sz="950" dirty="0">
                 <a:solidFill>
                   <a:srgbClr val="1B2A30"/>
                 </a:solidFill>
@@ -24895,7 +27488,7 @@
               </a:rPr>
               <a:t> — texture, temperature, color, papillomas, fissures, wounds, fungal infection between digits</a:t>
             </a:r>
-            <a:endParaRPr lang="en-US" sz="1050" dirty="0"/>
+            <a:endParaRPr lang="en-US" sz="950" dirty="0"/>
           </a:p>
           <a:p>
             <a:pPr marL="190500" indent="-190500">
@@ -24906,7 +27499,7 @@
               <a:buChar char="•"/>
             </a:pPr>
             <a:r>
-              <a:rPr lang="en-US" sz="1050" b="1" dirty="0">
+              <a:rPr lang="en-US" sz="950" b="1" dirty="0">
                 <a:solidFill>
                   <a:srgbClr val="1B2A30"/>
                 </a:solidFill>
@@ -24923,7 +27516,7 @@
               <a:buNone/>
             </a:pPr>
             <a:r>
-              <a:rPr lang="en-US" sz="1050" dirty="0">
+              <a:rPr lang="en-US" sz="950" dirty="0">
                 <a:solidFill>
                   <a:srgbClr val="1B2A30"/>
                 </a:solidFill>
@@ -24933,7 +27526,7 @@
               </a:rPr>
               <a:t> — symmetry, foot involvement, where the swelling stops</a:t>
             </a:r>
-            <a:endParaRPr lang="en-US" sz="1050" dirty="0"/>
+            <a:endParaRPr lang="en-US" sz="950" dirty="0"/>
           </a:p>
         </p:txBody>
       </p:sp>

</xml_diff>